<commit_message>
Add AXI4-Lite SoC project bundle
</commit_message>
<xml_diff>
--- a/reports/20260619_AXI4_Lite_Waveform_Analysis.pptx
+++ b/reports/20260619_AXI4_Lite_Waveform_Analysis.pptx
@@ -3378,91 +3378,6 @@
           </a:p>
         </p:txBody>
       </p:sp>
-      <p:sp>
-        <p:nvSpPr>
-          <p:cNvPr id="3" name="TextBox 2">
-            <a:extLst>
-              <a:ext uri="{FF2B5EF4-FFF2-40B4-BE49-F238E27FC236}">
-                <a16:creationId xmlns:a16="http://schemas.microsoft.com/office/drawing/2014/main" id="{B631F86D-EE5E-56F3-8D9A-42832C181873}"/>
-              </a:ext>
-            </a:extLst>
-          </p:cNvPr>
-          <p:cNvSpPr txBox="1"/>
-          <p:nvPr/>
-        </p:nvSpPr>
-        <p:spPr>
-          <a:xfrm>
-            <a:off x="457200" y="698500"/>
-            <a:ext cx="10795000" cy="235962"/>
-          </a:xfrm>
-          <a:prstGeom prst="rect">
-            <a:avLst/>
-          </a:prstGeom>
-          <a:noFill/>
-        </p:spPr>
-        <p:txBody>
-          <a:bodyPr vert="horz" lIns="63500" tIns="25400" rIns="63500" bIns="25400" rtlCol="0">
-            <a:spAutoFit/>
-          </a:bodyPr>
-          <a:lstStyle/>
-          <a:p>
-            <a:r>
-              <a:rPr lang="en-US" altLang="ko-KR" sz="1200">
-                <a:solidFill>
-                  <a:srgbClr val="404040"/>
-                </a:solidFill>
-                <a:latin typeface="Malgun Gothic" panose="020B0503020000020004" pitchFamily="50" charset="-127"/>
-              </a:rPr>
-              <a:t>Scope/Object </a:t>
-            </a:r>
-            <a:r>
-              <a:rPr lang="ko-KR" altLang="en-US" sz="1200">
-                <a:solidFill>
-                  <a:srgbClr val="404040"/>
-                </a:solidFill>
-                <a:latin typeface="Malgun Gothic" panose="020B0503020000020004" pitchFamily="50" charset="-127"/>
-              </a:rPr>
-              <a:t>패널 제외</a:t>
-            </a:r>
-            <a:r>
-              <a:rPr lang="en-US" altLang="ko-KR" sz="1200">
-                <a:solidFill>
-                  <a:srgbClr val="404040"/>
-                </a:solidFill>
-                <a:latin typeface="Malgun Gothic" panose="020B0503020000020004" pitchFamily="50" charset="-127"/>
-              </a:rPr>
-              <a:t>, </a:t>
-            </a:r>
-            <a:r>
-              <a:rPr lang="ko-KR" altLang="en-US" sz="1200">
-                <a:solidFill>
-                  <a:srgbClr val="404040"/>
-                </a:solidFill>
-                <a:latin typeface="Malgun Gothic" panose="020B0503020000020004" pitchFamily="50" charset="-127"/>
-              </a:rPr>
-              <a:t>실제 </a:t>
-            </a:r>
-            <a:r>
-              <a:rPr lang="en-US" altLang="ko-KR" sz="1200">
-                <a:solidFill>
-                  <a:srgbClr val="404040"/>
-                </a:solidFill>
-                <a:latin typeface="Malgun Gothic" panose="020B0503020000020004" pitchFamily="50" charset="-127"/>
-              </a:rPr>
-              <a:t>Vivado waveform viewer </a:t>
-            </a:r>
-            <a:r>
-              <a:rPr lang="ko-KR" altLang="en-US" sz="1200">
-                <a:solidFill>
-                  <a:srgbClr val="404040"/>
-                </a:solidFill>
-                <a:latin typeface="Malgun Gothic" panose="020B0503020000020004" pitchFamily="50" charset="-127"/>
-              </a:rPr>
-              <a:t>영역만 캡처</a:t>
-            </a:r>
-          </a:p>
-        </p:txBody>
-      </p:sp>
       <p:pic>
         <p:nvPicPr>
           <p:cNvPr id="5" name="그림 4">
@@ -3711,6 +3626,36 @@
           <a:chExt cx="0" cy="0"/>
         </a:xfrm>
       </p:grpSpPr>
+      <p:pic>
+        <p:nvPicPr>
+          <p:cNvPr id="17" name="그림 16">
+            <a:extLst>
+              <a:ext uri="{FF2B5EF4-FFF2-40B4-BE49-F238E27FC236}">
+                <a16:creationId xmlns:a16="http://schemas.microsoft.com/office/drawing/2014/main" id="{74B1403E-6F49-4EB4-910E-31AC013D4753}"/>
+              </a:ext>
+            </a:extLst>
+          </p:cNvPr>
+          <p:cNvPicPr>
+            <a:picLocks noGrp="1" noRot="1" noChangeAspect="1" noMove="1" noResize="1" noEditPoints="1" noAdjustHandles="1" noChangeArrowheads="1" noChangeShapeType="1" noCrop="1"/>
+          </p:cNvPicPr>
+          <p:nvPr/>
+        </p:nvPicPr>
+        <p:blipFill>
+          <a:blip r:embed="rId2"/>
+          <a:stretch>
+            <a:fillRect/>
+          </a:stretch>
+        </p:blipFill>
+        <p:spPr>
+          <a:xfrm>
+            <a:off x="0" y="1261937"/>
+            <a:ext cx="8064071" cy="4510213"/>
+          </a:xfrm>
+          <a:prstGeom prst="rect">
+            <a:avLst/>
+          </a:prstGeom>
+        </p:spPr>
+      </p:pic>
       <p:sp>
         <p:nvSpPr>
           <p:cNvPr id="2" name="TextBox 1">
@@ -3757,47 +3702,6 @@
           </a:p>
         </p:txBody>
       </p:sp>
-      <p:pic>
-        <p:nvPicPr>
-          <p:cNvPr id="4" name="그림 3">
-            <a:extLst>
-              <a:ext uri="{FF2B5EF4-FFF2-40B4-BE49-F238E27FC236}">
-                <a16:creationId xmlns:a16="http://schemas.microsoft.com/office/drawing/2014/main" id="{7083C40F-A995-85E9-9065-C1016D8527AE}"/>
-              </a:ext>
-            </a:extLst>
-          </p:cNvPr>
-          <p:cNvPicPr>
-            <a:picLocks/>
-          </p:cNvPicPr>
-          <p:nvPr/>
-        </p:nvPicPr>
-        <p:blipFill>
-          <a:blip r:embed="rId2">
-            <a:extLst>
-              <a:ext uri="{28A0092B-C50C-407E-A947-70E740481C1C}">
-                <a14:useLocalDpi xmlns:a14="http://schemas.microsoft.com/office/drawing/2010/main" val="0"/>
-              </a:ext>
-            </a:extLst>
-          </a:blip>
-          <a:stretch>
-            <a:fillRect/>
-          </a:stretch>
-        </p:blipFill>
-        <p:spPr>
-          <a:xfrm>
-            <a:off x="355600" y="762000"/>
-            <a:ext cx="7112000" cy="5080000"/>
-          </a:xfrm>
-          <a:prstGeom prst="rect">
-            <a:avLst/>
-          </a:prstGeom>
-          <a:ln w="12700">
-            <a:solidFill>
-              <a:schemeClr val="tx1"/>
-            </a:solidFill>
-          </a:ln>
-        </p:spPr>
-      </p:pic>
       <p:sp>
         <p:nvSpPr>
           <p:cNvPr id="5" name="직사각형 4">
@@ -3812,8 +3716,8 @@
         </p:nvSpPr>
         <p:spPr>
           <a:xfrm>
-            <a:off x="2857500" y="2921000"/>
-            <a:ext cx="4267200" cy="2349500"/>
+            <a:off x="2405670" y="1914717"/>
+            <a:ext cx="336506" cy="276162"/>
           </a:xfrm>
           <a:prstGeom prst="rect">
             <a:avLst/>
@@ -3862,48 +3766,6 @@
           </a:p>
         </p:txBody>
       </p:sp>
-      <p:cxnSp>
-        <p:nvCxnSpPr>
-          <p:cNvPr id="6" name="직선 연결선 5">
-            <a:extLst>
-              <a:ext uri="{FF2B5EF4-FFF2-40B4-BE49-F238E27FC236}">
-                <a16:creationId xmlns:a16="http://schemas.microsoft.com/office/drawing/2014/main" id="{1E14E546-F60A-BAA6-922F-7CF47FB0CB80}"/>
-              </a:ext>
-            </a:extLst>
-          </p:cNvPr>
-          <p:cNvCxnSpPr/>
-          <p:nvPr/>
-        </p:nvCxnSpPr>
-        <p:spPr>
-          <a:xfrm flipV="1">
-            <a:off x="6350000" y="1587500"/>
-            <a:ext cx="1905000" cy="1308100"/>
-          </a:xfrm>
-          <a:prstGeom prst="line">
-            <a:avLst/>
-          </a:prstGeom>
-          <a:ln w="28575">
-            <a:solidFill>
-              <a:srgbClr val="FF0000"/>
-            </a:solidFill>
-            <a:tailEnd type="arrow"/>
-          </a:ln>
-        </p:spPr>
-        <p:style>
-          <a:lnRef idx="2">
-            <a:schemeClr val="accent1"/>
-          </a:lnRef>
-          <a:fillRef idx="0">
-            <a:schemeClr val="accent1"/>
-          </a:fillRef>
-          <a:effectRef idx="1">
-            <a:schemeClr val="accent1"/>
-          </a:effectRef>
-          <a:fontRef idx="minor">
-            <a:schemeClr val="tx1"/>
-          </a:fontRef>
-        </p:style>
-      </p:cxnSp>
       <p:sp>
         <p:nvSpPr>
           <p:cNvPr id="7" name="사각형: 둥근 모서리 6">
@@ -3918,7 +3780,7 @@
         </p:nvSpPr>
         <p:spPr>
           <a:xfrm>
-            <a:off x="7937500" y="1041400"/>
+            <a:off x="8342536" y="1329835"/>
             <a:ext cx="3619500" cy="1371600"/>
           </a:xfrm>
           <a:prstGeom prst="roundRect">
@@ -4061,7 +3923,7 @@
         </p:nvSpPr>
         <p:spPr>
           <a:xfrm>
-            <a:off x="7937500" y="2794000"/>
+            <a:off x="8297958" y="4156566"/>
             <a:ext cx="3619500" cy="1371600"/>
           </a:xfrm>
           <a:prstGeom prst="roundRect">
@@ -4098,16 +3960,25 @@
           <a:p>
             <a:pPr algn="ctr"/>
             <a:r>
-              <a:rPr lang="en-US" altLang="ko-KR" sz="1200">
-                <a:solidFill>
-                  <a:srgbClr val="000000"/>
-                </a:solidFill>
-                <a:latin typeface="Malgun Gothic" panose="020B0503020000020004" pitchFamily="50" charset="-127"/>
-              </a:rPr>
-              <a:t>addr/AWADDR</a:t>
-            </a:r>
-            <a:r>
-              <a:rPr lang="ko-KR" altLang="en-US" sz="1200">
+              <a:rPr lang="en-US" altLang="ko-KR" sz="1200" dirty="0" err="1">
+                <a:solidFill>
+                  <a:srgbClr val="000000"/>
+                </a:solidFill>
+                <a:latin typeface="Malgun Gothic" panose="020B0503020000020004" pitchFamily="50" charset="-127"/>
+              </a:rPr>
+              <a:t>addr</a:t>
+            </a:r>
+            <a:r>
+              <a:rPr lang="en-US" altLang="ko-KR" sz="1200" dirty="0">
+                <a:solidFill>
+                  <a:srgbClr val="000000"/>
+                </a:solidFill>
+                <a:latin typeface="Malgun Gothic" panose="020B0503020000020004" pitchFamily="50" charset="-127"/>
+              </a:rPr>
+              <a:t>/AWADDR</a:t>
+            </a:r>
+            <a:r>
+              <a:rPr lang="ko-KR" altLang="en-US" sz="1200" dirty="0">
                 <a:solidFill>
                   <a:srgbClr val="000000"/>
                 </a:solidFill>
@@ -4116,16 +3987,25 @@
               <a:t>와 </a:t>
             </a:r>
             <a:r>
-              <a:rPr lang="en-US" altLang="ko-KR" sz="1200">
-                <a:solidFill>
-                  <a:srgbClr val="000000"/>
-                </a:solidFill>
-                <a:latin typeface="Malgun Gothic" panose="020B0503020000020004" pitchFamily="50" charset="-127"/>
-              </a:rPr>
-              <a:t>wdata/WDATA</a:t>
-            </a:r>
-            <a:r>
-              <a:rPr lang="ko-KR" altLang="en-US" sz="1200">
+              <a:rPr lang="en-US" altLang="ko-KR" sz="1200" dirty="0" err="1">
+                <a:solidFill>
+                  <a:srgbClr val="000000"/>
+                </a:solidFill>
+                <a:latin typeface="Malgun Gothic" panose="020B0503020000020004" pitchFamily="50" charset="-127"/>
+              </a:rPr>
+              <a:t>wdata</a:t>
+            </a:r>
+            <a:r>
+              <a:rPr lang="en-US" altLang="ko-KR" sz="1200" dirty="0">
+                <a:solidFill>
+                  <a:srgbClr val="000000"/>
+                </a:solidFill>
+                <a:latin typeface="Malgun Gothic" panose="020B0503020000020004" pitchFamily="50" charset="-127"/>
+              </a:rPr>
+              <a:t>/WDATA</a:t>
+            </a:r>
+            <a:r>
+              <a:rPr lang="ko-KR" altLang="en-US" sz="1200" dirty="0">
                 <a:solidFill>
                   <a:srgbClr val="000000"/>
                 </a:solidFill>
@@ -4134,7 +4014,7 @@
               <a:t>가 같은 순서로 </a:t>
             </a:r>
             <a:r>
-              <a:rPr lang="en-US" altLang="ko-KR" sz="1200">
+              <a:rPr lang="en-US" altLang="ko-KR" sz="1200" dirty="0">
                 <a:solidFill>
                   <a:srgbClr val="000000"/>
                 </a:solidFill>
@@ -4143,7 +4023,7 @@
               <a:t>0x00, 0x04, 0x08, 0x0C </a:t>
             </a:r>
             <a:r>
-              <a:rPr lang="ko-KR" altLang="en-US" sz="1200">
+              <a:rPr lang="ko-KR" altLang="en-US" sz="1200" dirty="0">
                 <a:solidFill>
                   <a:srgbClr val="000000"/>
                 </a:solidFill>
@@ -4152,7 +4032,7 @@
               <a:t>및 </a:t>
             </a:r>
             <a:r>
-              <a:rPr lang="en-US" altLang="ko-KR" sz="1200">
+              <a:rPr lang="en-US" altLang="ko-KR" sz="1200" dirty="0">
                 <a:solidFill>
                   <a:srgbClr val="000000"/>
                 </a:solidFill>
@@ -4161,7 +4041,7 @@
               <a:t>11111111~44444444</a:t>
             </a:r>
             <a:r>
-              <a:rPr lang="ko-KR" altLang="en-US" sz="1200">
+              <a:rPr lang="ko-KR" altLang="en-US" sz="1200" dirty="0">
                 <a:solidFill>
                   <a:srgbClr val="000000"/>
                 </a:solidFill>
@@ -4170,16 +4050,33 @@
               <a:t>를 전달한다</a:t>
             </a:r>
             <a:r>
-              <a:rPr lang="en-US" altLang="ko-KR" sz="1200">
-                <a:solidFill>
-                  <a:srgbClr val="000000"/>
-                </a:solidFill>
-                <a:latin typeface="Malgun Gothic" panose="020B0503020000020004" pitchFamily="50" charset="-127"/>
-              </a:rPr>
-              <a:t>. slave</a:t>
-            </a:r>
-            <a:r>
-              <a:rPr lang="ko-KR" altLang="en-US" sz="1200">
+              <a:rPr lang="en-US" altLang="ko-KR" sz="1200" dirty="0">
+                <a:solidFill>
+                  <a:srgbClr val="000000"/>
+                </a:solidFill>
+                <a:latin typeface="Malgun Gothic" panose="020B0503020000020004" pitchFamily="50" charset="-127"/>
+              </a:rPr>
+              <a:t>. </a:t>
+            </a:r>
+            <a:br>
+              <a:rPr lang="en-US" altLang="ko-KR" sz="1200" dirty="0">
+                <a:solidFill>
+                  <a:srgbClr val="000000"/>
+                </a:solidFill>
+                <a:latin typeface="Malgun Gothic" panose="020B0503020000020004" pitchFamily="50" charset="-127"/>
+              </a:rPr>
+            </a:br>
+            <a:r>
+              <a:rPr lang="en-US" altLang="ko-KR" sz="1200" dirty="0">
+                <a:solidFill>
+                  <a:srgbClr val="000000"/>
+                </a:solidFill>
+                <a:latin typeface="Malgun Gothic" panose="020B0503020000020004" pitchFamily="50" charset="-127"/>
+              </a:rPr>
+              <a:t>slave</a:t>
+            </a:r>
+            <a:r>
+              <a:rPr lang="ko-KR" altLang="en-US" sz="1200" dirty="0">
                 <a:solidFill>
                   <a:srgbClr val="000000"/>
                 </a:solidFill>
@@ -4188,7 +4085,7 @@
               <a:t>는 각 </a:t>
             </a:r>
             <a:r>
-              <a:rPr lang="en-US" altLang="ko-KR" sz="1200">
+              <a:rPr lang="en-US" altLang="ko-KR" sz="1200" dirty="0">
                 <a:solidFill>
                   <a:srgbClr val="000000"/>
                 </a:solidFill>
@@ -4197,7 +4094,7 @@
               <a:t>transaction</a:t>
             </a:r>
             <a:r>
-              <a:rPr lang="ko-KR" altLang="en-US" sz="1200">
+              <a:rPr lang="ko-KR" altLang="en-US" sz="1200" dirty="0">
                 <a:solidFill>
                   <a:srgbClr val="000000"/>
                 </a:solidFill>
@@ -4205,8 +4102,16 @@
               </a:rPr>
               <a:t>마다 </a:t>
             </a:r>
-            <a:r>
-              <a:rPr lang="en-US" altLang="ko-KR" sz="1200">
+            <a:br>
+              <a:rPr lang="en-US" altLang="ko-KR" sz="1200" dirty="0">
+                <a:solidFill>
+                  <a:srgbClr val="000000"/>
+                </a:solidFill>
+                <a:latin typeface="Malgun Gothic" panose="020B0503020000020004" pitchFamily="50" charset="-127"/>
+              </a:rPr>
+            </a:br>
+            <a:r>
+              <a:rPr lang="en-US" altLang="ko-KR" sz="1200" dirty="0">
                 <a:solidFill>
                   <a:srgbClr val="000000"/>
                 </a:solidFill>
@@ -4215,7 +4120,7 @@
               <a:t>BVALID/BRESP</a:t>
             </a:r>
             <a:r>
-              <a:rPr lang="ko-KR" altLang="en-US" sz="1200">
+              <a:rPr lang="ko-KR" altLang="en-US" sz="1200" dirty="0">
                 <a:solidFill>
                   <a:srgbClr val="000000"/>
                 </a:solidFill>
@@ -4224,7 +4129,7 @@
               <a:t>로 정상 응답한다</a:t>
             </a:r>
             <a:r>
-              <a:rPr lang="en-US" altLang="ko-KR" sz="1200">
+              <a:rPr lang="en-US" altLang="ko-KR" sz="1200" dirty="0">
                 <a:solidFill>
                   <a:srgbClr val="000000"/>
                 </a:solidFill>
@@ -4232,7 +4137,7 @@
               </a:rPr>
               <a:t>.</a:t>
             </a:r>
-            <a:endParaRPr lang="ko-KR" altLang="en-US" sz="1200">
+            <a:endParaRPr lang="ko-KR" altLang="en-US" sz="1200" dirty="0">
               <a:solidFill>
                 <a:srgbClr val="000000"/>
               </a:solidFill>
@@ -4697,6 +4602,754 @@
           </a:p>
         </p:txBody>
       </p:sp>
+      <p:sp>
+        <p:nvSpPr>
+          <p:cNvPr id="21" name="직사각형 20">
+            <a:extLst>
+              <a:ext uri="{FF2B5EF4-FFF2-40B4-BE49-F238E27FC236}">
+                <a16:creationId xmlns:a16="http://schemas.microsoft.com/office/drawing/2014/main" id="{A2A097A6-600E-B8B5-CA65-9B54FFD0540A}"/>
+              </a:ext>
+            </a:extLst>
+          </p:cNvPr>
+          <p:cNvSpPr/>
+          <p:nvPr/>
+        </p:nvSpPr>
+        <p:spPr>
+          <a:xfrm>
+            <a:off x="3368143" y="1913695"/>
+            <a:ext cx="336506" cy="276162"/>
+          </a:xfrm>
+          <a:prstGeom prst="rect">
+            <a:avLst/>
+          </a:prstGeom>
+          <a:noFill/>
+          <a:ln w="28575" cap="flat" cmpd="sng" algn="ctr">
+            <a:solidFill>
+              <a:srgbClr val="FF0000"/>
+            </a:solidFill>
+            <a:prstDash val="solid"/>
+            <a:miter lim="800000"/>
+          </a:ln>
+          <a:effectLst/>
+          <a:extLst>
+            <a:ext uri="{909E8E84-426E-40DD-AFC4-6F175D3DCCD1}">
+              <a14:hiddenFill xmlns:a14="http://schemas.microsoft.com/office/drawing/2010/main">
+                <a:solidFill>
+                  <a:schemeClr val="accent1"/>
+                </a:solidFill>
+              </a14:hiddenFill>
+            </a:ext>
+          </a:extLst>
+        </p:spPr>
+        <p:style>
+          <a:lnRef idx="2">
+            <a:schemeClr val="accent1">
+              <a:shade val="15000"/>
+            </a:schemeClr>
+          </a:lnRef>
+          <a:fillRef idx="1">
+            <a:schemeClr val="accent1"/>
+          </a:fillRef>
+          <a:effectRef idx="0">
+            <a:schemeClr val="accent1"/>
+          </a:effectRef>
+          <a:fontRef idx="minor">
+            <a:schemeClr val="lt1"/>
+          </a:fontRef>
+        </p:style>
+        <p:txBody>
+          <a:bodyPr rtlCol="0" anchor="ctr"/>
+          <a:lstStyle/>
+          <a:p>
+            <a:pPr algn="ctr"/>
+            <a:endParaRPr lang="ko-KR" altLang="en-US"/>
+          </a:p>
+        </p:txBody>
+      </p:sp>
+      <p:sp>
+        <p:nvSpPr>
+          <p:cNvPr id="22" name="직사각형 21">
+            <a:extLst>
+              <a:ext uri="{FF2B5EF4-FFF2-40B4-BE49-F238E27FC236}">
+                <a16:creationId xmlns:a16="http://schemas.microsoft.com/office/drawing/2014/main" id="{FBAD7CE5-A28D-074C-F6EB-C1055177A136}"/>
+              </a:ext>
+            </a:extLst>
+          </p:cNvPr>
+          <p:cNvSpPr/>
+          <p:nvPr/>
+        </p:nvSpPr>
+        <p:spPr>
+          <a:xfrm>
+            <a:off x="4354992" y="1914717"/>
+            <a:ext cx="336506" cy="276162"/>
+          </a:xfrm>
+          <a:prstGeom prst="rect">
+            <a:avLst/>
+          </a:prstGeom>
+          <a:noFill/>
+          <a:ln w="28575" cap="flat" cmpd="sng" algn="ctr">
+            <a:solidFill>
+              <a:srgbClr val="FF0000"/>
+            </a:solidFill>
+            <a:prstDash val="solid"/>
+            <a:miter lim="800000"/>
+          </a:ln>
+          <a:effectLst/>
+          <a:extLst>
+            <a:ext uri="{909E8E84-426E-40DD-AFC4-6F175D3DCCD1}">
+              <a14:hiddenFill xmlns:a14="http://schemas.microsoft.com/office/drawing/2010/main">
+                <a:solidFill>
+                  <a:schemeClr val="accent1"/>
+                </a:solidFill>
+              </a14:hiddenFill>
+            </a:ext>
+          </a:extLst>
+        </p:spPr>
+        <p:style>
+          <a:lnRef idx="2">
+            <a:schemeClr val="accent1">
+              <a:shade val="15000"/>
+            </a:schemeClr>
+          </a:lnRef>
+          <a:fillRef idx="1">
+            <a:schemeClr val="accent1"/>
+          </a:fillRef>
+          <a:effectRef idx="0">
+            <a:schemeClr val="accent1"/>
+          </a:effectRef>
+          <a:fontRef idx="minor">
+            <a:schemeClr val="lt1"/>
+          </a:fontRef>
+        </p:style>
+        <p:txBody>
+          <a:bodyPr rtlCol="0" anchor="ctr"/>
+          <a:lstStyle/>
+          <a:p>
+            <a:pPr algn="ctr"/>
+            <a:endParaRPr lang="ko-KR" altLang="en-US"/>
+          </a:p>
+        </p:txBody>
+      </p:sp>
+      <p:sp>
+        <p:nvSpPr>
+          <p:cNvPr id="23" name="직사각형 22">
+            <a:extLst>
+              <a:ext uri="{FF2B5EF4-FFF2-40B4-BE49-F238E27FC236}">
+                <a16:creationId xmlns:a16="http://schemas.microsoft.com/office/drawing/2014/main" id="{D51D7033-6A40-E07D-9775-86990F574AB2}"/>
+              </a:ext>
+            </a:extLst>
+          </p:cNvPr>
+          <p:cNvSpPr/>
+          <p:nvPr/>
+        </p:nvSpPr>
+        <p:spPr>
+          <a:xfrm>
+            <a:off x="5317465" y="1913695"/>
+            <a:ext cx="336506" cy="276162"/>
+          </a:xfrm>
+          <a:prstGeom prst="rect">
+            <a:avLst/>
+          </a:prstGeom>
+          <a:noFill/>
+          <a:ln w="28575" cap="flat" cmpd="sng" algn="ctr">
+            <a:solidFill>
+              <a:srgbClr val="FF0000"/>
+            </a:solidFill>
+            <a:prstDash val="solid"/>
+            <a:miter lim="800000"/>
+          </a:ln>
+          <a:effectLst/>
+          <a:extLst>
+            <a:ext uri="{909E8E84-426E-40DD-AFC4-6F175D3DCCD1}">
+              <a14:hiddenFill xmlns:a14="http://schemas.microsoft.com/office/drawing/2010/main">
+                <a:solidFill>
+                  <a:schemeClr val="accent1"/>
+                </a:solidFill>
+              </a14:hiddenFill>
+            </a:ext>
+          </a:extLst>
+        </p:spPr>
+        <p:style>
+          <a:lnRef idx="2">
+            <a:schemeClr val="accent1">
+              <a:shade val="15000"/>
+            </a:schemeClr>
+          </a:lnRef>
+          <a:fillRef idx="1">
+            <a:schemeClr val="accent1"/>
+          </a:fillRef>
+          <a:effectRef idx="0">
+            <a:schemeClr val="accent1"/>
+          </a:effectRef>
+          <a:fontRef idx="minor">
+            <a:schemeClr val="lt1"/>
+          </a:fontRef>
+        </p:style>
+        <p:txBody>
+          <a:bodyPr rtlCol="0" anchor="ctr"/>
+          <a:lstStyle/>
+          <a:p>
+            <a:pPr algn="ctr"/>
+            <a:endParaRPr lang="ko-KR" altLang="en-US"/>
+          </a:p>
+        </p:txBody>
+      </p:sp>
+      <p:sp>
+        <p:nvSpPr>
+          <p:cNvPr id="28" name="직사각형 27">
+            <a:extLst>
+              <a:ext uri="{FF2B5EF4-FFF2-40B4-BE49-F238E27FC236}">
+                <a16:creationId xmlns:a16="http://schemas.microsoft.com/office/drawing/2014/main" id="{4DA43C44-DC08-C724-617A-99880ED05749}"/>
+              </a:ext>
+            </a:extLst>
+          </p:cNvPr>
+          <p:cNvSpPr/>
+          <p:nvPr/>
+        </p:nvSpPr>
+        <p:spPr>
+          <a:xfrm>
+            <a:off x="2405670" y="2361307"/>
+            <a:ext cx="336506" cy="276162"/>
+          </a:xfrm>
+          <a:prstGeom prst="rect">
+            <a:avLst/>
+          </a:prstGeom>
+          <a:noFill/>
+          <a:ln w="28575" cap="flat" cmpd="sng" algn="ctr">
+            <a:solidFill>
+              <a:srgbClr val="FF0000"/>
+            </a:solidFill>
+            <a:prstDash val="solid"/>
+            <a:miter lim="800000"/>
+          </a:ln>
+          <a:effectLst/>
+          <a:extLst>
+            <a:ext uri="{909E8E84-426E-40DD-AFC4-6F175D3DCCD1}">
+              <a14:hiddenFill xmlns:a14="http://schemas.microsoft.com/office/drawing/2010/main">
+                <a:solidFill>
+                  <a:schemeClr val="accent1"/>
+                </a:solidFill>
+              </a14:hiddenFill>
+            </a:ext>
+          </a:extLst>
+        </p:spPr>
+        <p:style>
+          <a:lnRef idx="2">
+            <a:schemeClr val="accent1">
+              <a:shade val="15000"/>
+            </a:schemeClr>
+          </a:lnRef>
+          <a:fillRef idx="1">
+            <a:schemeClr val="accent1"/>
+          </a:fillRef>
+          <a:effectRef idx="0">
+            <a:schemeClr val="accent1"/>
+          </a:effectRef>
+          <a:fontRef idx="minor">
+            <a:schemeClr val="lt1"/>
+          </a:fontRef>
+        </p:style>
+        <p:txBody>
+          <a:bodyPr rtlCol="0" anchor="ctr"/>
+          <a:lstStyle/>
+          <a:p>
+            <a:pPr algn="ctr"/>
+            <a:endParaRPr lang="ko-KR" altLang="en-US"/>
+          </a:p>
+        </p:txBody>
+      </p:sp>
+      <p:sp>
+        <p:nvSpPr>
+          <p:cNvPr id="29" name="직사각형 28">
+            <a:extLst>
+              <a:ext uri="{FF2B5EF4-FFF2-40B4-BE49-F238E27FC236}">
+                <a16:creationId xmlns:a16="http://schemas.microsoft.com/office/drawing/2014/main" id="{0B7DD87B-01EF-5DAB-9486-A2011D051EA9}"/>
+              </a:ext>
+            </a:extLst>
+          </p:cNvPr>
+          <p:cNvSpPr/>
+          <p:nvPr/>
+        </p:nvSpPr>
+        <p:spPr>
+          <a:xfrm>
+            <a:off x="3368143" y="2360285"/>
+            <a:ext cx="336506" cy="276162"/>
+          </a:xfrm>
+          <a:prstGeom prst="rect">
+            <a:avLst/>
+          </a:prstGeom>
+          <a:noFill/>
+          <a:ln w="28575" cap="flat" cmpd="sng" algn="ctr">
+            <a:solidFill>
+              <a:srgbClr val="FF0000"/>
+            </a:solidFill>
+            <a:prstDash val="solid"/>
+            <a:miter lim="800000"/>
+          </a:ln>
+          <a:effectLst/>
+          <a:extLst>
+            <a:ext uri="{909E8E84-426E-40DD-AFC4-6F175D3DCCD1}">
+              <a14:hiddenFill xmlns:a14="http://schemas.microsoft.com/office/drawing/2010/main">
+                <a:solidFill>
+                  <a:schemeClr val="accent1"/>
+                </a:solidFill>
+              </a14:hiddenFill>
+            </a:ext>
+          </a:extLst>
+        </p:spPr>
+        <p:style>
+          <a:lnRef idx="2">
+            <a:schemeClr val="accent1">
+              <a:shade val="15000"/>
+            </a:schemeClr>
+          </a:lnRef>
+          <a:fillRef idx="1">
+            <a:schemeClr val="accent1"/>
+          </a:fillRef>
+          <a:effectRef idx="0">
+            <a:schemeClr val="accent1"/>
+          </a:effectRef>
+          <a:fontRef idx="minor">
+            <a:schemeClr val="lt1"/>
+          </a:fontRef>
+        </p:style>
+        <p:txBody>
+          <a:bodyPr rtlCol="0" anchor="ctr"/>
+          <a:lstStyle/>
+          <a:p>
+            <a:pPr algn="ctr"/>
+            <a:endParaRPr lang="ko-KR" altLang="en-US"/>
+          </a:p>
+        </p:txBody>
+      </p:sp>
+      <p:sp>
+        <p:nvSpPr>
+          <p:cNvPr id="30" name="직사각형 29">
+            <a:extLst>
+              <a:ext uri="{FF2B5EF4-FFF2-40B4-BE49-F238E27FC236}">
+                <a16:creationId xmlns:a16="http://schemas.microsoft.com/office/drawing/2014/main" id="{123E3750-8D94-52A0-8520-FCA4C27F5FE3}"/>
+              </a:ext>
+            </a:extLst>
+          </p:cNvPr>
+          <p:cNvSpPr/>
+          <p:nvPr/>
+        </p:nvSpPr>
+        <p:spPr>
+          <a:xfrm>
+            <a:off x="4354992" y="2361307"/>
+            <a:ext cx="336506" cy="276162"/>
+          </a:xfrm>
+          <a:prstGeom prst="rect">
+            <a:avLst/>
+          </a:prstGeom>
+          <a:noFill/>
+          <a:ln w="28575" cap="flat" cmpd="sng" algn="ctr">
+            <a:solidFill>
+              <a:srgbClr val="FF0000"/>
+            </a:solidFill>
+            <a:prstDash val="solid"/>
+            <a:miter lim="800000"/>
+          </a:ln>
+          <a:effectLst/>
+          <a:extLst>
+            <a:ext uri="{909E8E84-426E-40DD-AFC4-6F175D3DCCD1}">
+              <a14:hiddenFill xmlns:a14="http://schemas.microsoft.com/office/drawing/2010/main">
+                <a:solidFill>
+                  <a:schemeClr val="accent1"/>
+                </a:solidFill>
+              </a14:hiddenFill>
+            </a:ext>
+          </a:extLst>
+        </p:spPr>
+        <p:style>
+          <a:lnRef idx="2">
+            <a:schemeClr val="accent1">
+              <a:shade val="15000"/>
+            </a:schemeClr>
+          </a:lnRef>
+          <a:fillRef idx="1">
+            <a:schemeClr val="accent1"/>
+          </a:fillRef>
+          <a:effectRef idx="0">
+            <a:schemeClr val="accent1"/>
+          </a:effectRef>
+          <a:fontRef idx="minor">
+            <a:schemeClr val="lt1"/>
+          </a:fontRef>
+        </p:style>
+        <p:txBody>
+          <a:bodyPr rtlCol="0" anchor="ctr"/>
+          <a:lstStyle/>
+          <a:p>
+            <a:pPr algn="ctr"/>
+            <a:endParaRPr lang="ko-KR" altLang="en-US"/>
+          </a:p>
+        </p:txBody>
+      </p:sp>
+      <p:sp>
+        <p:nvSpPr>
+          <p:cNvPr id="31" name="직사각형 30">
+            <a:extLst>
+              <a:ext uri="{FF2B5EF4-FFF2-40B4-BE49-F238E27FC236}">
+                <a16:creationId xmlns:a16="http://schemas.microsoft.com/office/drawing/2014/main" id="{82B54674-24A0-7D84-EB0E-1CF68C85EC9D}"/>
+              </a:ext>
+            </a:extLst>
+          </p:cNvPr>
+          <p:cNvSpPr/>
+          <p:nvPr/>
+        </p:nvSpPr>
+        <p:spPr>
+          <a:xfrm>
+            <a:off x="5317465" y="2360285"/>
+            <a:ext cx="336506" cy="276162"/>
+          </a:xfrm>
+          <a:prstGeom prst="rect">
+            <a:avLst/>
+          </a:prstGeom>
+          <a:noFill/>
+          <a:ln w="28575" cap="flat" cmpd="sng" algn="ctr">
+            <a:solidFill>
+              <a:srgbClr val="FF0000"/>
+            </a:solidFill>
+            <a:prstDash val="solid"/>
+            <a:miter lim="800000"/>
+          </a:ln>
+          <a:effectLst/>
+          <a:extLst>
+            <a:ext uri="{909E8E84-426E-40DD-AFC4-6F175D3DCCD1}">
+              <a14:hiddenFill xmlns:a14="http://schemas.microsoft.com/office/drawing/2010/main">
+                <a:solidFill>
+                  <a:schemeClr val="accent1"/>
+                </a:solidFill>
+              </a14:hiddenFill>
+            </a:ext>
+          </a:extLst>
+        </p:spPr>
+        <p:style>
+          <a:lnRef idx="2">
+            <a:schemeClr val="accent1">
+              <a:shade val="15000"/>
+            </a:schemeClr>
+          </a:lnRef>
+          <a:fillRef idx="1">
+            <a:schemeClr val="accent1"/>
+          </a:fillRef>
+          <a:effectRef idx="0">
+            <a:schemeClr val="accent1"/>
+          </a:effectRef>
+          <a:fontRef idx="minor">
+            <a:schemeClr val="lt1"/>
+          </a:fontRef>
+        </p:style>
+        <p:txBody>
+          <a:bodyPr rtlCol="0" anchor="ctr"/>
+          <a:lstStyle/>
+          <a:p>
+            <a:pPr algn="ctr"/>
+            <a:endParaRPr lang="ko-KR" altLang="en-US"/>
+          </a:p>
+        </p:txBody>
+      </p:sp>
+      <p:sp>
+        <p:nvSpPr>
+          <p:cNvPr id="36" name="직사각형 35">
+            <a:extLst>
+              <a:ext uri="{FF2B5EF4-FFF2-40B4-BE49-F238E27FC236}">
+                <a16:creationId xmlns:a16="http://schemas.microsoft.com/office/drawing/2014/main" id="{F2205FB3-0A62-0871-28D4-8CB5BF3B995C}"/>
+              </a:ext>
+            </a:extLst>
+          </p:cNvPr>
+          <p:cNvSpPr/>
+          <p:nvPr/>
+        </p:nvSpPr>
+        <p:spPr>
+          <a:xfrm>
+            <a:off x="2597620" y="2758541"/>
+            <a:ext cx="336506" cy="276162"/>
+          </a:xfrm>
+          <a:prstGeom prst="rect">
+            <a:avLst/>
+          </a:prstGeom>
+          <a:noFill/>
+          <a:ln w="28575" cap="flat" cmpd="sng" algn="ctr">
+            <a:solidFill>
+              <a:srgbClr val="FF0000"/>
+            </a:solidFill>
+            <a:prstDash val="solid"/>
+            <a:miter lim="800000"/>
+          </a:ln>
+          <a:effectLst/>
+          <a:extLst>
+            <a:ext uri="{909E8E84-426E-40DD-AFC4-6F175D3DCCD1}">
+              <a14:hiddenFill xmlns:a14="http://schemas.microsoft.com/office/drawing/2010/main">
+                <a:solidFill>
+                  <a:schemeClr val="accent1"/>
+                </a:solidFill>
+              </a14:hiddenFill>
+            </a:ext>
+          </a:extLst>
+        </p:spPr>
+        <p:style>
+          <a:lnRef idx="2">
+            <a:schemeClr val="accent1">
+              <a:shade val="15000"/>
+            </a:schemeClr>
+          </a:lnRef>
+          <a:fillRef idx="1">
+            <a:schemeClr val="accent1"/>
+          </a:fillRef>
+          <a:effectRef idx="0">
+            <a:schemeClr val="accent1"/>
+          </a:effectRef>
+          <a:fontRef idx="minor">
+            <a:schemeClr val="lt1"/>
+          </a:fontRef>
+        </p:style>
+        <p:txBody>
+          <a:bodyPr rtlCol="0" anchor="ctr"/>
+          <a:lstStyle/>
+          <a:p>
+            <a:pPr algn="ctr"/>
+            <a:endParaRPr lang="ko-KR" altLang="en-US"/>
+          </a:p>
+        </p:txBody>
+      </p:sp>
+      <p:sp>
+        <p:nvSpPr>
+          <p:cNvPr id="37" name="직사각형 36">
+            <a:extLst>
+              <a:ext uri="{FF2B5EF4-FFF2-40B4-BE49-F238E27FC236}">
+                <a16:creationId xmlns:a16="http://schemas.microsoft.com/office/drawing/2014/main" id="{C31D083E-2DA5-4029-0C6C-4B5866C16212}"/>
+              </a:ext>
+            </a:extLst>
+          </p:cNvPr>
+          <p:cNvSpPr/>
+          <p:nvPr/>
+        </p:nvSpPr>
+        <p:spPr>
+          <a:xfrm>
+            <a:off x="3560093" y="2757519"/>
+            <a:ext cx="336506" cy="276162"/>
+          </a:xfrm>
+          <a:prstGeom prst="rect">
+            <a:avLst/>
+          </a:prstGeom>
+          <a:noFill/>
+          <a:ln w="28575" cap="flat" cmpd="sng" algn="ctr">
+            <a:solidFill>
+              <a:srgbClr val="FF0000"/>
+            </a:solidFill>
+            <a:prstDash val="solid"/>
+            <a:miter lim="800000"/>
+          </a:ln>
+          <a:effectLst/>
+          <a:extLst>
+            <a:ext uri="{909E8E84-426E-40DD-AFC4-6F175D3DCCD1}">
+              <a14:hiddenFill xmlns:a14="http://schemas.microsoft.com/office/drawing/2010/main">
+                <a:solidFill>
+                  <a:schemeClr val="accent1"/>
+                </a:solidFill>
+              </a14:hiddenFill>
+            </a:ext>
+          </a:extLst>
+        </p:spPr>
+        <p:style>
+          <a:lnRef idx="2">
+            <a:schemeClr val="accent1">
+              <a:shade val="15000"/>
+            </a:schemeClr>
+          </a:lnRef>
+          <a:fillRef idx="1">
+            <a:schemeClr val="accent1"/>
+          </a:fillRef>
+          <a:effectRef idx="0">
+            <a:schemeClr val="accent1"/>
+          </a:effectRef>
+          <a:fontRef idx="minor">
+            <a:schemeClr val="lt1"/>
+          </a:fontRef>
+        </p:style>
+        <p:txBody>
+          <a:bodyPr rtlCol="0" anchor="ctr"/>
+          <a:lstStyle/>
+          <a:p>
+            <a:pPr algn="ctr"/>
+            <a:endParaRPr lang="ko-KR" altLang="en-US"/>
+          </a:p>
+        </p:txBody>
+      </p:sp>
+      <p:sp>
+        <p:nvSpPr>
+          <p:cNvPr id="38" name="직사각형 37">
+            <a:extLst>
+              <a:ext uri="{FF2B5EF4-FFF2-40B4-BE49-F238E27FC236}">
+                <a16:creationId xmlns:a16="http://schemas.microsoft.com/office/drawing/2014/main" id="{FC8A237C-DEE8-E98D-8331-E3D989505C75}"/>
+              </a:ext>
+            </a:extLst>
+          </p:cNvPr>
+          <p:cNvSpPr/>
+          <p:nvPr/>
+        </p:nvSpPr>
+        <p:spPr>
+          <a:xfrm>
+            <a:off x="4546942" y="2758541"/>
+            <a:ext cx="336506" cy="276162"/>
+          </a:xfrm>
+          <a:prstGeom prst="rect">
+            <a:avLst/>
+          </a:prstGeom>
+          <a:noFill/>
+          <a:ln w="28575" cap="flat" cmpd="sng" algn="ctr">
+            <a:solidFill>
+              <a:srgbClr val="FF0000"/>
+            </a:solidFill>
+            <a:prstDash val="solid"/>
+            <a:miter lim="800000"/>
+          </a:ln>
+          <a:effectLst/>
+          <a:extLst>
+            <a:ext uri="{909E8E84-426E-40DD-AFC4-6F175D3DCCD1}">
+              <a14:hiddenFill xmlns:a14="http://schemas.microsoft.com/office/drawing/2010/main">
+                <a:solidFill>
+                  <a:schemeClr val="accent1"/>
+                </a:solidFill>
+              </a14:hiddenFill>
+            </a:ext>
+          </a:extLst>
+        </p:spPr>
+        <p:style>
+          <a:lnRef idx="2">
+            <a:schemeClr val="accent1">
+              <a:shade val="15000"/>
+            </a:schemeClr>
+          </a:lnRef>
+          <a:fillRef idx="1">
+            <a:schemeClr val="accent1"/>
+          </a:fillRef>
+          <a:effectRef idx="0">
+            <a:schemeClr val="accent1"/>
+          </a:effectRef>
+          <a:fontRef idx="minor">
+            <a:schemeClr val="lt1"/>
+          </a:fontRef>
+        </p:style>
+        <p:txBody>
+          <a:bodyPr rtlCol="0" anchor="ctr"/>
+          <a:lstStyle/>
+          <a:p>
+            <a:pPr algn="ctr"/>
+            <a:endParaRPr lang="ko-KR" altLang="en-US"/>
+          </a:p>
+        </p:txBody>
+      </p:sp>
+      <p:sp>
+        <p:nvSpPr>
+          <p:cNvPr id="39" name="직사각형 38">
+            <a:extLst>
+              <a:ext uri="{FF2B5EF4-FFF2-40B4-BE49-F238E27FC236}">
+                <a16:creationId xmlns:a16="http://schemas.microsoft.com/office/drawing/2014/main" id="{7D96FA70-51C1-478D-38D9-8A4702BBC975}"/>
+              </a:ext>
+            </a:extLst>
+          </p:cNvPr>
+          <p:cNvSpPr/>
+          <p:nvPr/>
+        </p:nvSpPr>
+        <p:spPr>
+          <a:xfrm>
+            <a:off x="5509415" y="2757519"/>
+            <a:ext cx="336506" cy="276162"/>
+          </a:xfrm>
+          <a:prstGeom prst="rect">
+            <a:avLst/>
+          </a:prstGeom>
+          <a:noFill/>
+          <a:ln w="28575" cap="flat" cmpd="sng" algn="ctr">
+            <a:solidFill>
+              <a:srgbClr val="FF0000"/>
+            </a:solidFill>
+            <a:prstDash val="solid"/>
+            <a:miter lim="800000"/>
+          </a:ln>
+          <a:effectLst/>
+          <a:extLst>
+            <a:ext uri="{909E8E84-426E-40DD-AFC4-6F175D3DCCD1}">
+              <a14:hiddenFill xmlns:a14="http://schemas.microsoft.com/office/drawing/2010/main">
+                <a:solidFill>
+                  <a:schemeClr val="accent1"/>
+                </a:solidFill>
+              </a14:hiddenFill>
+            </a:ext>
+          </a:extLst>
+        </p:spPr>
+        <p:style>
+          <a:lnRef idx="2">
+            <a:schemeClr val="accent1">
+              <a:shade val="15000"/>
+            </a:schemeClr>
+          </a:lnRef>
+          <a:fillRef idx="1">
+            <a:schemeClr val="accent1"/>
+          </a:fillRef>
+          <a:effectRef idx="0">
+            <a:schemeClr val="accent1"/>
+          </a:effectRef>
+          <a:fontRef idx="minor">
+            <a:schemeClr val="lt1"/>
+          </a:fontRef>
+        </p:style>
+        <p:txBody>
+          <a:bodyPr rtlCol="0" anchor="ctr"/>
+          <a:lstStyle/>
+          <a:p>
+            <a:pPr algn="ctr"/>
+            <a:endParaRPr lang="ko-KR" altLang="en-US"/>
+          </a:p>
+        </p:txBody>
+      </p:sp>
+      <p:cxnSp>
+        <p:nvCxnSpPr>
+          <p:cNvPr id="6" name="직선 연결선 5">
+            <a:extLst>
+              <a:ext uri="{FF2B5EF4-FFF2-40B4-BE49-F238E27FC236}">
+                <a16:creationId xmlns:a16="http://schemas.microsoft.com/office/drawing/2014/main" id="{1E14E546-F60A-BAA6-922F-7CF47FB0CB80}"/>
+              </a:ext>
+            </a:extLst>
+          </p:cNvPr>
+          <p:cNvCxnSpPr>
+            <a:cxnSpLocks/>
+          </p:cNvCxnSpPr>
+          <p:nvPr/>
+        </p:nvCxnSpPr>
+        <p:spPr>
+          <a:xfrm flipH="1">
+            <a:off x="5906521" y="1983885"/>
+            <a:ext cx="2436015" cy="440196"/>
+          </a:xfrm>
+          <a:prstGeom prst="line">
+            <a:avLst/>
+          </a:prstGeom>
+          <a:ln w="28575">
+            <a:solidFill>
+              <a:srgbClr val="FF0000"/>
+            </a:solidFill>
+            <a:tailEnd type="arrow"/>
+          </a:ln>
+        </p:spPr>
+        <p:style>
+          <a:lnRef idx="2">
+            <a:schemeClr val="accent1"/>
+          </a:lnRef>
+          <a:fillRef idx="0">
+            <a:schemeClr val="accent1"/>
+          </a:fillRef>
+          <a:effectRef idx="1">
+            <a:schemeClr val="accent1"/>
+          </a:effectRef>
+          <a:fontRef idx="minor">
+            <a:schemeClr val="tx1"/>
+          </a:fontRef>
+        </p:style>
+      </p:cxnSp>
     </p:spTree>
     <p:extLst>
       <p:ext uri="{BB962C8B-B14F-4D97-AF65-F5344CB8AC3E}">
@@ -4727,6 +5380,36 @@
           <a:chExt cx="0" cy="0"/>
         </a:xfrm>
       </p:grpSpPr>
+      <p:pic>
+        <p:nvPicPr>
+          <p:cNvPr id="17" name="그림 16">
+            <a:extLst>
+              <a:ext uri="{FF2B5EF4-FFF2-40B4-BE49-F238E27FC236}">
+                <a16:creationId xmlns:a16="http://schemas.microsoft.com/office/drawing/2014/main" id="{0F5BC573-3E68-5E9F-0EE8-2591442033D8}"/>
+              </a:ext>
+            </a:extLst>
+          </p:cNvPr>
+          <p:cNvPicPr>
+            <a:picLocks noGrp="1" noRot="1" noChangeAspect="1" noMove="1" noResize="1" noEditPoints="1" noAdjustHandles="1" noChangeArrowheads="1" noChangeShapeType="1" noCrop="1"/>
+          </p:cNvPicPr>
+          <p:nvPr/>
+        </p:nvPicPr>
+        <p:blipFill>
+          <a:blip r:embed="rId2"/>
+          <a:stretch>
+            <a:fillRect/>
+          </a:stretch>
+        </p:blipFill>
+        <p:spPr>
+          <a:xfrm>
+            <a:off x="458221" y="669250"/>
+            <a:ext cx="7694125" cy="5147350"/>
+          </a:xfrm>
+          <a:prstGeom prst="rect">
+            <a:avLst/>
+          </a:prstGeom>
+        </p:spPr>
+      </p:pic>
       <p:sp>
         <p:nvSpPr>
           <p:cNvPr id="2" name="TextBox 1">
@@ -4773,53 +5456,805 @@
           </a:p>
         </p:txBody>
       </p:sp>
-      <p:pic>
-        <p:nvPicPr>
-          <p:cNvPr id="4" name="그림 3">
-            <a:extLst>
-              <a:ext uri="{FF2B5EF4-FFF2-40B4-BE49-F238E27FC236}">
-                <a16:creationId xmlns:a16="http://schemas.microsoft.com/office/drawing/2014/main" id="{238B60A2-CE0B-03C6-7AC6-5286C37A9457}"/>
-              </a:ext>
-            </a:extLst>
-          </p:cNvPr>
-          <p:cNvPicPr>
-            <a:picLocks/>
-          </p:cNvPicPr>
+      <p:sp>
+        <p:nvSpPr>
+          <p:cNvPr id="7" name="사각형: 둥근 모서리 6">
+            <a:extLst>
+              <a:ext uri="{FF2B5EF4-FFF2-40B4-BE49-F238E27FC236}">
+                <a16:creationId xmlns:a16="http://schemas.microsoft.com/office/drawing/2014/main" id="{08A83FA5-B3EA-B3EE-7545-F7A4153B2AEF}"/>
+              </a:ext>
+            </a:extLst>
+          </p:cNvPr>
+          <p:cNvSpPr/>
           <p:nvPr/>
-        </p:nvPicPr>
-        <p:blipFill>
-          <a:blip r:embed="rId2">
-            <a:extLst>
-              <a:ext uri="{28A0092B-C50C-407E-A947-70E740481C1C}">
-                <a14:useLocalDpi xmlns:a14="http://schemas.microsoft.com/office/drawing/2010/main" val="0"/>
-              </a:ext>
-            </a:extLst>
-          </a:blip>
-          <a:stretch>
-            <a:fillRect/>
-          </a:stretch>
-        </p:blipFill>
-        <p:spPr>
-          <a:xfrm>
-            <a:off x="355600" y="762000"/>
-            <a:ext cx="7112000" cy="5080000"/>
+        </p:nvSpPr>
+        <p:spPr>
+          <a:xfrm>
+            <a:off x="8330136" y="799507"/>
+            <a:ext cx="3619500" cy="1549400"/>
+          </a:xfrm>
+          <a:prstGeom prst="roundRect">
+            <a:avLst/>
+          </a:prstGeom>
+          <a:solidFill>
+            <a:srgbClr val="ECF9FF"/>
+          </a:solidFill>
+          <a:ln w="15875">
+            <a:solidFill>
+              <a:srgbClr val="ADADAD"/>
+            </a:solidFill>
+          </a:ln>
+        </p:spPr>
+        <p:style>
+          <a:lnRef idx="2">
+            <a:schemeClr val="accent1">
+              <a:shade val="15000"/>
+            </a:schemeClr>
+          </a:lnRef>
+          <a:fillRef idx="1">
+            <a:schemeClr val="accent1"/>
+          </a:fillRef>
+          <a:effectRef idx="0">
+            <a:schemeClr val="accent1"/>
+          </a:effectRef>
+          <a:fontRef idx="minor">
+            <a:schemeClr val="lt1"/>
+          </a:fontRef>
+        </p:style>
+        <p:txBody>
+          <a:bodyPr lIns="101600" tIns="63500" rIns="101600" bIns="63500" rtlCol="0" anchor="ctr"/>
+          <a:lstStyle/>
+          <a:p>
+            <a:pPr algn="ctr"/>
+            <a:r>
+              <a:rPr lang="en-US" altLang="ko-KR" sz="1200" dirty="0">
+                <a:solidFill>
+                  <a:srgbClr val="000000"/>
+                </a:solidFill>
+                <a:latin typeface="Malgun Gothic" panose="020B0503020000020004" pitchFamily="50" charset="-127"/>
+              </a:rPr>
+              <a:t>AR/R </a:t>
+            </a:r>
+            <a:r>
+              <a:rPr lang="ko-KR" altLang="en-US" sz="1200" dirty="0">
+                <a:solidFill>
+                  <a:srgbClr val="000000"/>
+                </a:solidFill>
+                <a:latin typeface="Malgun Gothic" panose="020B0503020000020004" pitchFamily="50" charset="-127"/>
+              </a:rPr>
+              <a:t>채널 </a:t>
+            </a:r>
+            <a:r>
+              <a:rPr lang="en-US" altLang="ko-KR" sz="1200" dirty="0">
+                <a:solidFill>
+                  <a:srgbClr val="000000"/>
+                </a:solidFill>
+                <a:latin typeface="Malgun Gothic" panose="020B0503020000020004" pitchFamily="50" charset="-127"/>
+              </a:rPr>
+              <a:t>handshake:</a:t>
+            </a:r>
+          </a:p>
+          <a:p>
+            <a:pPr algn="ctr"/>
+            <a:r>
+              <a:rPr lang="en-US" altLang="ko-KR" sz="1200" dirty="0">
+                <a:solidFill>
+                  <a:srgbClr val="000000"/>
+                </a:solidFill>
+                <a:latin typeface="Malgun Gothic" panose="020B0503020000020004" pitchFamily="50" charset="-127"/>
+              </a:rPr>
+              <a:t>ARVALID-ARREADY: read </a:t>
+            </a:r>
+            <a:r>
+              <a:rPr lang="ko-KR" altLang="en-US" sz="1200" dirty="0">
+                <a:solidFill>
+                  <a:srgbClr val="000000"/>
+                </a:solidFill>
+                <a:latin typeface="Malgun Gothic" panose="020B0503020000020004" pitchFamily="50" charset="-127"/>
+              </a:rPr>
+              <a:t>주소 수락</a:t>
+            </a:r>
+          </a:p>
+          <a:p>
+            <a:pPr algn="ctr"/>
+            <a:r>
+              <a:rPr lang="en-US" altLang="ko-KR" sz="1200" dirty="0">
+                <a:solidFill>
+                  <a:srgbClr val="000000"/>
+                </a:solidFill>
+                <a:latin typeface="Malgun Gothic" panose="020B0503020000020004" pitchFamily="50" charset="-127"/>
+              </a:rPr>
+              <a:t>RVALID-RREADY: read data phase </a:t>
+            </a:r>
+            <a:r>
+              <a:rPr lang="ko-KR" altLang="en-US" sz="1200" dirty="0">
+                <a:solidFill>
+                  <a:srgbClr val="000000"/>
+                </a:solidFill>
+                <a:latin typeface="Malgun Gothic" panose="020B0503020000020004" pitchFamily="50" charset="-127"/>
+              </a:rPr>
+              <a:t>완료</a:t>
+            </a:r>
+          </a:p>
+          <a:p>
+            <a:pPr algn="ctr"/>
+            <a:r>
+              <a:rPr lang="en-US" altLang="ko-KR" sz="1200" dirty="0">
+                <a:solidFill>
+                  <a:srgbClr val="000000"/>
+                </a:solidFill>
+                <a:latin typeface="Malgun Gothic" panose="020B0503020000020004" pitchFamily="50" charset="-127"/>
+              </a:rPr>
+              <a:t>RRESP=0: OKAY </a:t>
+            </a:r>
+            <a:r>
+              <a:rPr lang="ko-KR" altLang="en-US" sz="1200" dirty="0">
+                <a:solidFill>
+                  <a:srgbClr val="000000"/>
+                </a:solidFill>
+                <a:latin typeface="Malgun Gothic" panose="020B0503020000020004" pitchFamily="50" charset="-127"/>
+              </a:rPr>
+              <a:t>응답</a:t>
+            </a:r>
+          </a:p>
+        </p:txBody>
+      </p:sp>
+      <p:sp>
+        <p:nvSpPr>
+          <p:cNvPr id="8" name="사각형: 둥근 모서리 7">
+            <a:extLst>
+              <a:ext uri="{FF2B5EF4-FFF2-40B4-BE49-F238E27FC236}">
+                <a16:creationId xmlns:a16="http://schemas.microsoft.com/office/drawing/2014/main" id="{F83D7C12-9F50-9ECB-85D0-CE8680505232}"/>
+              </a:ext>
+            </a:extLst>
+          </p:cNvPr>
+          <p:cNvSpPr/>
+          <p:nvPr/>
+        </p:nvSpPr>
+        <p:spPr>
+          <a:xfrm>
+            <a:off x="8255000" y="3919612"/>
+            <a:ext cx="3619500" cy="1422400"/>
+          </a:xfrm>
+          <a:prstGeom prst="roundRect">
+            <a:avLst/>
+          </a:prstGeom>
+          <a:solidFill>
+            <a:srgbClr val="F2F2F2"/>
+          </a:solidFill>
+          <a:ln w="15875">
+            <a:solidFill>
+              <a:srgbClr val="FF0000"/>
+            </a:solidFill>
+          </a:ln>
+        </p:spPr>
+        <p:style>
+          <a:lnRef idx="2">
+            <a:schemeClr val="accent1">
+              <a:shade val="15000"/>
+            </a:schemeClr>
+          </a:lnRef>
+          <a:fillRef idx="1">
+            <a:schemeClr val="accent1"/>
+          </a:fillRef>
+          <a:effectRef idx="0">
+            <a:schemeClr val="accent1"/>
+          </a:effectRef>
+          <a:fontRef idx="minor">
+            <a:schemeClr val="lt1"/>
+          </a:fontRef>
+        </p:style>
+        <p:txBody>
+          <a:bodyPr lIns="101600" tIns="63500" rIns="101600" bIns="63500" rtlCol="0" anchor="ctr"/>
+          <a:lstStyle/>
+          <a:p>
+            <a:pPr algn="ctr"/>
+            <a:r>
+              <a:rPr lang="en-US" altLang="ko-KR" sz="1200">
+                <a:solidFill>
+                  <a:srgbClr val="000000"/>
+                </a:solidFill>
+                <a:latin typeface="Malgun Gothic" panose="020B0503020000020004" pitchFamily="50" charset="-127"/>
+              </a:rPr>
+              <a:t>ARADDR </a:t>
+            </a:r>
+            <a:r>
+              <a:rPr lang="ko-KR" altLang="en-US" sz="1200">
+                <a:solidFill>
+                  <a:srgbClr val="000000"/>
+                </a:solidFill>
+                <a:latin typeface="Malgun Gothic" panose="020B0503020000020004" pitchFamily="50" charset="-127"/>
+              </a:rPr>
+              <a:t>요청 순서와 </a:t>
+            </a:r>
+            <a:r>
+              <a:rPr lang="en-US" altLang="ko-KR" sz="1200">
+                <a:solidFill>
+                  <a:srgbClr val="000000"/>
+                </a:solidFill>
+                <a:latin typeface="Malgun Gothic" panose="020B0503020000020004" pitchFamily="50" charset="-127"/>
+              </a:rPr>
+              <a:t>RDATA </a:t>
+            </a:r>
+            <a:r>
+              <a:rPr lang="ko-KR" altLang="en-US" sz="1200">
+                <a:solidFill>
+                  <a:srgbClr val="000000"/>
+                </a:solidFill>
+                <a:latin typeface="Malgun Gothic" panose="020B0503020000020004" pitchFamily="50" charset="-127"/>
+              </a:rPr>
+              <a:t>반환 순서가 </a:t>
+            </a:r>
+            <a:r>
+              <a:rPr lang="en-US" altLang="ko-KR" sz="1200">
+                <a:solidFill>
+                  <a:srgbClr val="000000"/>
+                </a:solidFill>
+                <a:latin typeface="Malgun Gothic" panose="020B0503020000020004" pitchFamily="50" charset="-127"/>
+              </a:rPr>
+              <a:t>write </a:t>
+            </a:r>
+            <a:r>
+              <a:rPr lang="ko-KR" altLang="en-US" sz="1200">
+                <a:solidFill>
+                  <a:srgbClr val="000000"/>
+                </a:solidFill>
+                <a:latin typeface="Malgun Gothic" panose="020B0503020000020004" pitchFamily="50" charset="-127"/>
+              </a:rPr>
+              <a:t>때 저장한 값과 일치한다</a:t>
+            </a:r>
+            <a:r>
+              <a:rPr lang="en-US" altLang="ko-KR" sz="1200">
+                <a:solidFill>
+                  <a:srgbClr val="000000"/>
+                </a:solidFill>
+                <a:latin typeface="Malgun Gothic" panose="020B0503020000020004" pitchFamily="50" charset="-127"/>
+              </a:rPr>
+              <a:t>. </a:t>
+            </a:r>
+            <a:r>
+              <a:rPr lang="ko-KR" altLang="en-US" sz="1200">
+                <a:solidFill>
+                  <a:srgbClr val="000000"/>
+                </a:solidFill>
+                <a:latin typeface="Malgun Gothic" panose="020B0503020000020004" pitchFamily="50" charset="-127"/>
+              </a:rPr>
+              <a:t>마지막 </a:t>
+            </a:r>
+            <a:r>
+              <a:rPr lang="en-US" altLang="ko-KR" sz="1200">
+                <a:solidFill>
+                  <a:srgbClr val="000000"/>
+                </a:solidFill>
+                <a:latin typeface="Malgun Gothic" panose="020B0503020000020004" pitchFamily="50" charset="-127"/>
+              </a:rPr>
+              <a:t>read</a:t>
+            </a:r>
+            <a:r>
+              <a:rPr lang="ko-KR" altLang="en-US" sz="1200">
+                <a:solidFill>
+                  <a:srgbClr val="000000"/>
+                </a:solidFill>
+                <a:latin typeface="Malgun Gothic" panose="020B0503020000020004" pitchFamily="50" charset="-127"/>
+              </a:rPr>
+              <a:t>에서는 </a:t>
+            </a:r>
+            <a:r>
+              <a:rPr lang="en-US" altLang="ko-KR" sz="1200">
+                <a:solidFill>
+                  <a:srgbClr val="000000"/>
+                </a:solidFill>
+                <a:latin typeface="Malgun Gothic" panose="020B0503020000020004" pitchFamily="50" charset="-127"/>
+              </a:rPr>
+              <a:t>RDATA=44444444</a:t>
+            </a:r>
+            <a:r>
+              <a:rPr lang="ko-KR" altLang="en-US" sz="1200">
+                <a:solidFill>
+                  <a:srgbClr val="000000"/>
+                </a:solidFill>
+                <a:latin typeface="Malgun Gothic" panose="020B0503020000020004" pitchFamily="50" charset="-127"/>
+              </a:rPr>
+              <a:t>가 관측되어 </a:t>
+            </a:r>
+            <a:r>
+              <a:rPr lang="en-US" altLang="ko-KR" sz="1200">
+                <a:solidFill>
+                  <a:srgbClr val="000000"/>
+                </a:solidFill>
+                <a:latin typeface="Malgun Gothic" panose="020B0503020000020004" pitchFamily="50" charset="-127"/>
+              </a:rPr>
+              <a:t>slv_reg3 readback</a:t>
+            </a:r>
+            <a:r>
+              <a:rPr lang="ko-KR" altLang="en-US" sz="1200">
+                <a:solidFill>
+                  <a:srgbClr val="000000"/>
+                </a:solidFill>
+                <a:latin typeface="Malgun Gothic" panose="020B0503020000020004" pitchFamily="50" charset="-127"/>
+              </a:rPr>
+              <a:t>이 정상임을 확인한다</a:t>
+            </a:r>
+            <a:r>
+              <a:rPr lang="en-US" altLang="ko-KR" sz="1200">
+                <a:solidFill>
+                  <a:srgbClr val="000000"/>
+                </a:solidFill>
+                <a:latin typeface="Malgun Gothic" panose="020B0503020000020004" pitchFamily="50" charset="-127"/>
+              </a:rPr>
+              <a:t>.</a:t>
+            </a:r>
+            <a:endParaRPr lang="ko-KR" altLang="en-US" sz="1200">
+              <a:solidFill>
+                <a:srgbClr val="000000"/>
+              </a:solidFill>
+              <a:latin typeface="Malgun Gothic" panose="020B0503020000020004" pitchFamily="50" charset="-127"/>
+            </a:endParaRPr>
+          </a:p>
+        </p:txBody>
+      </p:sp>
+      <p:sp>
+        <p:nvSpPr>
+          <p:cNvPr id="9" name="사각형: 둥근 모서리 8">
+            <a:extLst>
+              <a:ext uri="{FF2B5EF4-FFF2-40B4-BE49-F238E27FC236}">
+                <a16:creationId xmlns:a16="http://schemas.microsoft.com/office/drawing/2014/main" id="{310A6073-53A1-ABBB-1C4B-04E424A8FBD0}"/>
+              </a:ext>
+            </a:extLst>
+          </p:cNvPr>
+          <p:cNvSpPr/>
+          <p:nvPr/>
+        </p:nvSpPr>
+        <p:spPr>
+          <a:xfrm>
+            <a:off x="1473200" y="5943600"/>
+            <a:ext cx="1168400" cy="279400"/>
+          </a:xfrm>
+          <a:prstGeom prst="roundRect">
+            <a:avLst/>
+          </a:prstGeom>
+          <a:solidFill>
+            <a:srgbClr val="0070C0"/>
+          </a:solidFill>
+          <a:ln>
+            <a:solidFill>
+              <a:srgbClr val="0070C0"/>
+            </a:solidFill>
+          </a:ln>
+        </p:spPr>
+        <p:style>
+          <a:lnRef idx="2">
+            <a:schemeClr val="accent1">
+              <a:shade val="15000"/>
+            </a:schemeClr>
+          </a:lnRef>
+          <a:fillRef idx="1">
+            <a:schemeClr val="accent1"/>
+          </a:fillRef>
+          <a:effectRef idx="0">
+            <a:schemeClr val="accent1"/>
+          </a:effectRef>
+          <a:fontRef idx="minor">
+            <a:schemeClr val="lt1"/>
+          </a:fontRef>
+        </p:style>
+        <p:txBody>
+          <a:bodyPr lIns="50800" tIns="12700" rIns="50800" bIns="12700" rtlCol="0" anchor="ctr"/>
+          <a:lstStyle/>
+          <a:p>
+            <a:pPr algn="ctr"/>
+            <a:r>
+              <a:rPr lang="en-US" altLang="ko-KR" sz="1100" b="1">
+                <a:solidFill>
+                  <a:srgbClr val="FFFFFF"/>
+                </a:solidFill>
+                <a:latin typeface="Malgun Gothic" panose="020B0503020000020004" pitchFamily="50" charset="-127"/>
+              </a:rPr>
+              <a:t>286 ns</a:t>
+            </a:r>
+            <a:endParaRPr lang="ko-KR" altLang="en-US" sz="1100" b="1">
+              <a:solidFill>
+                <a:srgbClr val="FFFFFF"/>
+              </a:solidFill>
+              <a:latin typeface="Malgun Gothic" panose="020B0503020000020004" pitchFamily="50" charset="-127"/>
+            </a:endParaRPr>
+          </a:p>
+        </p:txBody>
+      </p:sp>
+      <p:sp>
+        <p:nvSpPr>
+          <p:cNvPr id="10" name="사각형: 둥근 모서리 9">
+            <a:extLst>
+              <a:ext uri="{FF2B5EF4-FFF2-40B4-BE49-F238E27FC236}">
+                <a16:creationId xmlns:a16="http://schemas.microsoft.com/office/drawing/2014/main" id="{61F86DF5-4D11-8DED-EA31-59E81E1CBCBA}"/>
+              </a:ext>
+            </a:extLst>
+          </p:cNvPr>
+          <p:cNvSpPr/>
+          <p:nvPr/>
+        </p:nvSpPr>
+        <p:spPr>
+          <a:xfrm>
+            <a:off x="2870200" y="5943600"/>
+            <a:ext cx="1168400" cy="279400"/>
+          </a:xfrm>
+          <a:prstGeom prst="roundRect">
+            <a:avLst/>
+          </a:prstGeom>
+          <a:solidFill>
+            <a:srgbClr val="0070C0"/>
+          </a:solidFill>
+          <a:ln>
+            <a:solidFill>
+              <a:srgbClr val="0070C0"/>
+            </a:solidFill>
+          </a:ln>
+        </p:spPr>
+        <p:style>
+          <a:lnRef idx="2">
+            <a:schemeClr val="accent1">
+              <a:shade val="15000"/>
+            </a:schemeClr>
+          </a:lnRef>
+          <a:fillRef idx="1">
+            <a:schemeClr val="accent1"/>
+          </a:fillRef>
+          <a:effectRef idx="0">
+            <a:schemeClr val="accent1"/>
+          </a:effectRef>
+          <a:fontRef idx="minor">
+            <a:schemeClr val="lt1"/>
+          </a:fontRef>
+        </p:style>
+        <p:txBody>
+          <a:bodyPr lIns="50800" tIns="12700" rIns="50800" bIns="12700" rtlCol="0" anchor="ctr"/>
+          <a:lstStyle/>
+          <a:p>
+            <a:pPr algn="ctr"/>
+            <a:r>
+              <a:rPr lang="en-US" altLang="ko-KR" sz="1100" b="1">
+                <a:solidFill>
+                  <a:srgbClr val="FFFFFF"/>
+                </a:solidFill>
+                <a:latin typeface="Malgun Gothic" panose="020B0503020000020004" pitchFamily="50" charset="-127"/>
+              </a:rPr>
+              <a:t>336 ns</a:t>
+            </a:r>
+            <a:endParaRPr lang="ko-KR" altLang="en-US" sz="1100" b="1">
+              <a:solidFill>
+                <a:srgbClr val="FFFFFF"/>
+              </a:solidFill>
+              <a:latin typeface="Malgun Gothic" panose="020B0503020000020004" pitchFamily="50" charset="-127"/>
+            </a:endParaRPr>
+          </a:p>
+        </p:txBody>
+      </p:sp>
+      <p:sp>
+        <p:nvSpPr>
+          <p:cNvPr id="11" name="사각형: 둥근 모서리 10">
+            <a:extLst>
+              <a:ext uri="{FF2B5EF4-FFF2-40B4-BE49-F238E27FC236}">
+                <a16:creationId xmlns:a16="http://schemas.microsoft.com/office/drawing/2014/main" id="{F8C83E4C-199E-EDBC-BEFE-85E542B7113A}"/>
+              </a:ext>
+            </a:extLst>
+          </p:cNvPr>
+          <p:cNvSpPr/>
+          <p:nvPr/>
+        </p:nvSpPr>
+        <p:spPr>
+          <a:xfrm>
+            <a:off x="4279900" y="5943600"/>
+            <a:ext cx="1168400" cy="279400"/>
+          </a:xfrm>
+          <a:prstGeom prst="roundRect">
+            <a:avLst/>
+          </a:prstGeom>
+          <a:solidFill>
+            <a:srgbClr val="0070C0"/>
+          </a:solidFill>
+          <a:ln>
+            <a:solidFill>
+              <a:srgbClr val="0070C0"/>
+            </a:solidFill>
+          </a:ln>
+        </p:spPr>
+        <p:style>
+          <a:lnRef idx="2">
+            <a:schemeClr val="accent1">
+              <a:shade val="15000"/>
+            </a:schemeClr>
+          </a:lnRef>
+          <a:fillRef idx="1">
+            <a:schemeClr val="accent1"/>
+          </a:fillRef>
+          <a:effectRef idx="0">
+            <a:schemeClr val="accent1"/>
+          </a:effectRef>
+          <a:fontRef idx="minor">
+            <a:schemeClr val="lt1"/>
+          </a:fontRef>
+        </p:style>
+        <p:txBody>
+          <a:bodyPr lIns="50800" tIns="12700" rIns="50800" bIns="12700" rtlCol="0" anchor="ctr"/>
+          <a:lstStyle/>
+          <a:p>
+            <a:pPr algn="ctr"/>
+            <a:r>
+              <a:rPr lang="en-US" altLang="ko-KR" sz="1100" b="1">
+                <a:solidFill>
+                  <a:srgbClr val="FFFFFF"/>
+                </a:solidFill>
+                <a:latin typeface="Malgun Gothic" panose="020B0503020000020004" pitchFamily="50" charset="-127"/>
+              </a:rPr>
+              <a:t>386 ns</a:t>
+            </a:r>
+            <a:endParaRPr lang="ko-KR" altLang="en-US" sz="1100" b="1">
+              <a:solidFill>
+                <a:srgbClr val="FFFFFF"/>
+              </a:solidFill>
+              <a:latin typeface="Malgun Gothic" panose="020B0503020000020004" pitchFamily="50" charset="-127"/>
+            </a:endParaRPr>
+          </a:p>
+        </p:txBody>
+      </p:sp>
+      <p:sp>
+        <p:nvSpPr>
+          <p:cNvPr id="12" name="사각형: 둥근 모서리 11">
+            <a:extLst>
+              <a:ext uri="{FF2B5EF4-FFF2-40B4-BE49-F238E27FC236}">
+                <a16:creationId xmlns:a16="http://schemas.microsoft.com/office/drawing/2014/main" id="{66E4166A-146B-B18A-D260-2F1C592F51B4}"/>
+              </a:ext>
+            </a:extLst>
+          </p:cNvPr>
+          <p:cNvSpPr/>
+          <p:nvPr/>
+        </p:nvSpPr>
+        <p:spPr>
+          <a:xfrm>
+            <a:off x="5689600" y="5943600"/>
+            <a:ext cx="1168400" cy="279400"/>
+          </a:xfrm>
+          <a:prstGeom prst="roundRect">
+            <a:avLst/>
+          </a:prstGeom>
+          <a:solidFill>
+            <a:srgbClr val="0070C0"/>
+          </a:solidFill>
+          <a:ln>
+            <a:solidFill>
+              <a:srgbClr val="0070C0"/>
+            </a:solidFill>
+          </a:ln>
+        </p:spPr>
+        <p:style>
+          <a:lnRef idx="2">
+            <a:schemeClr val="accent1">
+              <a:shade val="15000"/>
+            </a:schemeClr>
+          </a:lnRef>
+          <a:fillRef idx="1">
+            <a:schemeClr val="accent1"/>
+          </a:fillRef>
+          <a:effectRef idx="0">
+            <a:schemeClr val="accent1"/>
+          </a:effectRef>
+          <a:fontRef idx="minor">
+            <a:schemeClr val="lt1"/>
+          </a:fontRef>
+        </p:style>
+        <p:txBody>
+          <a:bodyPr lIns="50800" tIns="12700" rIns="50800" bIns="12700" rtlCol="0" anchor="ctr"/>
+          <a:lstStyle/>
+          <a:p>
+            <a:pPr algn="ctr"/>
+            <a:r>
+              <a:rPr lang="en-US" altLang="ko-KR" sz="1100" b="1">
+                <a:solidFill>
+                  <a:srgbClr val="FFFFFF"/>
+                </a:solidFill>
+                <a:latin typeface="Malgun Gothic" panose="020B0503020000020004" pitchFamily="50" charset="-127"/>
+              </a:rPr>
+              <a:t>436 ns</a:t>
+            </a:r>
+            <a:endParaRPr lang="ko-KR" altLang="en-US" sz="1100" b="1">
+              <a:solidFill>
+                <a:srgbClr val="FFFFFF"/>
+              </a:solidFill>
+              <a:latin typeface="Malgun Gothic" panose="020B0503020000020004" pitchFamily="50" charset="-127"/>
+            </a:endParaRPr>
+          </a:p>
+        </p:txBody>
+      </p:sp>
+      <p:sp>
+        <p:nvSpPr>
+          <p:cNvPr id="13" name="TextBox 12">
+            <a:extLst>
+              <a:ext uri="{FF2B5EF4-FFF2-40B4-BE49-F238E27FC236}">
+                <a16:creationId xmlns:a16="http://schemas.microsoft.com/office/drawing/2014/main" id="{D24CDA76-80AE-6097-E4EC-C83C1D53A90A}"/>
+              </a:ext>
+            </a:extLst>
+          </p:cNvPr>
+          <p:cNvSpPr txBox="1"/>
+          <p:nvPr/>
+        </p:nvSpPr>
+        <p:spPr>
+          <a:xfrm>
+            <a:off x="1320800" y="6273800"/>
+            <a:ext cx="1473200" cy="205184"/>
           </a:xfrm>
           <a:prstGeom prst="rect">
             <a:avLst/>
           </a:prstGeom>
-          <a:ln w="12700">
-            <a:solidFill>
-              <a:schemeClr val="tx1"/>
-            </a:solidFill>
-          </a:ln>
-        </p:spPr>
-      </p:pic>
-      <p:sp>
-        <p:nvSpPr>
-          <p:cNvPr id="5" name="직사각형 4">
-            <a:extLst>
-              <a:ext uri="{FF2B5EF4-FFF2-40B4-BE49-F238E27FC236}">
-                <a16:creationId xmlns:a16="http://schemas.microsoft.com/office/drawing/2014/main" id="{051AEB0E-82FF-1537-89B4-B4D212BAAFFA}"/>
+          <a:noFill/>
+        </p:spPr>
+        <p:txBody>
+          <a:bodyPr vert="horz" lIns="63500" tIns="25400" rIns="63500" bIns="25400" rtlCol="0">
+            <a:spAutoFit/>
+          </a:bodyPr>
+          <a:lstStyle/>
+          <a:p>
+            <a:r>
+              <a:rPr lang="en-US" altLang="ko-KR" sz="1000">
+                <a:solidFill>
+                  <a:srgbClr val="000000"/>
+                </a:solidFill>
+                <a:latin typeface="Malgun Gothic" panose="020B0503020000020004" pitchFamily="50" charset="-127"/>
+              </a:rPr>
+              <a:t>0x00 -&gt; 11111111</a:t>
+            </a:r>
+            <a:endParaRPr lang="ko-KR" altLang="en-US" sz="1000">
+              <a:solidFill>
+                <a:srgbClr val="000000"/>
+              </a:solidFill>
+              <a:latin typeface="Malgun Gothic" panose="020B0503020000020004" pitchFamily="50" charset="-127"/>
+            </a:endParaRPr>
+          </a:p>
+        </p:txBody>
+      </p:sp>
+      <p:sp>
+        <p:nvSpPr>
+          <p:cNvPr id="14" name="TextBox 13">
+            <a:extLst>
+              <a:ext uri="{FF2B5EF4-FFF2-40B4-BE49-F238E27FC236}">
+                <a16:creationId xmlns:a16="http://schemas.microsoft.com/office/drawing/2014/main" id="{3DD46D91-A811-241C-5861-BE441C8B70AF}"/>
+              </a:ext>
+            </a:extLst>
+          </p:cNvPr>
+          <p:cNvSpPr txBox="1"/>
+          <p:nvPr/>
+        </p:nvSpPr>
+        <p:spPr>
+          <a:xfrm>
+            <a:off x="2717800" y="6273800"/>
+            <a:ext cx="1473200" cy="205184"/>
+          </a:xfrm>
+          <a:prstGeom prst="rect">
+            <a:avLst/>
+          </a:prstGeom>
+          <a:noFill/>
+        </p:spPr>
+        <p:txBody>
+          <a:bodyPr vert="horz" lIns="63500" tIns="25400" rIns="63500" bIns="25400" rtlCol="0">
+            <a:spAutoFit/>
+          </a:bodyPr>
+          <a:lstStyle/>
+          <a:p>
+            <a:r>
+              <a:rPr lang="en-US" altLang="ko-KR" sz="1000">
+                <a:solidFill>
+                  <a:srgbClr val="000000"/>
+                </a:solidFill>
+                <a:latin typeface="Malgun Gothic" panose="020B0503020000020004" pitchFamily="50" charset="-127"/>
+              </a:rPr>
+              <a:t>0x04 -&gt; 22222222</a:t>
+            </a:r>
+            <a:endParaRPr lang="ko-KR" altLang="en-US" sz="1000">
+              <a:solidFill>
+                <a:srgbClr val="000000"/>
+              </a:solidFill>
+              <a:latin typeface="Malgun Gothic" panose="020B0503020000020004" pitchFamily="50" charset="-127"/>
+            </a:endParaRPr>
+          </a:p>
+        </p:txBody>
+      </p:sp>
+      <p:sp>
+        <p:nvSpPr>
+          <p:cNvPr id="15" name="TextBox 14">
+            <a:extLst>
+              <a:ext uri="{FF2B5EF4-FFF2-40B4-BE49-F238E27FC236}">
+                <a16:creationId xmlns:a16="http://schemas.microsoft.com/office/drawing/2014/main" id="{46EAF054-3075-DE4A-6A5A-C0F69FD7AC66}"/>
+              </a:ext>
+            </a:extLst>
+          </p:cNvPr>
+          <p:cNvSpPr txBox="1"/>
+          <p:nvPr/>
+        </p:nvSpPr>
+        <p:spPr>
+          <a:xfrm>
+            <a:off x="4140200" y="6273800"/>
+            <a:ext cx="1473200" cy="205184"/>
+          </a:xfrm>
+          <a:prstGeom prst="rect">
+            <a:avLst/>
+          </a:prstGeom>
+          <a:noFill/>
+        </p:spPr>
+        <p:txBody>
+          <a:bodyPr vert="horz" lIns="63500" tIns="25400" rIns="63500" bIns="25400" rtlCol="0">
+            <a:spAutoFit/>
+          </a:bodyPr>
+          <a:lstStyle/>
+          <a:p>
+            <a:r>
+              <a:rPr lang="en-US" altLang="ko-KR" sz="1000">
+                <a:solidFill>
+                  <a:srgbClr val="000000"/>
+                </a:solidFill>
+                <a:latin typeface="Malgun Gothic" panose="020B0503020000020004" pitchFamily="50" charset="-127"/>
+              </a:rPr>
+              <a:t>0x08 -&gt; 33333333</a:t>
+            </a:r>
+            <a:endParaRPr lang="ko-KR" altLang="en-US" sz="1000">
+              <a:solidFill>
+                <a:srgbClr val="000000"/>
+              </a:solidFill>
+              <a:latin typeface="Malgun Gothic" panose="020B0503020000020004" pitchFamily="50" charset="-127"/>
+            </a:endParaRPr>
+          </a:p>
+        </p:txBody>
+      </p:sp>
+      <p:sp>
+        <p:nvSpPr>
+          <p:cNvPr id="16" name="TextBox 15">
+            <a:extLst>
+              <a:ext uri="{FF2B5EF4-FFF2-40B4-BE49-F238E27FC236}">
+                <a16:creationId xmlns:a16="http://schemas.microsoft.com/office/drawing/2014/main" id="{48830B1D-45AA-F360-7600-97353C6AB15C}"/>
+              </a:ext>
+            </a:extLst>
+          </p:cNvPr>
+          <p:cNvSpPr txBox="1"/>
+          <p:nvPr/>
+        </p:nvSpPr>
+        <p:spPr>
+          <a:xfrm>
+            <a:off x="5562600" y="6273800"/>
+            <a:ext cx="1473200" cy="205184"/>
+          </a:xfrm>
+          <a:prstGeom prst="rect">
+            <a:avLst/>
+          </a:prstGeom>
+          <a:noFill/>
+        </p:spPr>
+        <p:txBody>
+          <a:bodyPr vert="horz" lIns="63500" tIns="25400" rIns="63500" bIns="25400" rtlCol="0">
+            <a:spAutoFit/>
+          </a:bodyPr>
+          <a:lstStyle/>
+          <a:p>
+            <a:r>
+              <a:rPr lang="en-US" altLang="ko-KR" sz="1000">
+                <a:solidFill>
+                  <a:srgbClr val="000000"/>
+                </a:solidFill>
+                <a:latin typeface="Malgun Gothic" panose="020B0503020000020004" pitchFamily="50" charset="-127"/>
+              </a:rPr>
+              <a:t>0x0C -&gt; 44444444</a:t>
+            </a:r>
+            <a:endParaRPr lang="ko-KR" altLang="en-US" sz="1000">
+              <a:solidFill>
+                <a:srgbClr val="000000"/>
+              </a:solidFill>
+              <a:latin typeface="Malgun Gothic" panose="020B0503020000020004" pitchFamily="50" charset="-127"/>
+            </a:endParaRPr>
+          </a:p>
+        </p:txBody>
+      </p:sp>
+      <p:sp>
+        <p:nvSpPr>
+          <p:cNvPr id="18" name="직사각형 17">
+            <a:extLst>
+              <a:ext uri="{FF2B5EF4-FFF2-40B4-BE49-F238E27FC236}">
+                <a16:creationId xmlns:a16="http://schemas.microsoft.com/office/drawing/2014/main" id="{DE1DADDC-5081-357A-204B-82A14E266026}"/>
               </a:ext>
             </a:extLst>
           </p:cNvPr>
@@ -4828,8 +6263,8 @@
         </p:nvSpPr>
         <p:spPr>
           <a:xfrm>
-            <a:off x="2857500" y="2768600"/>
-            <a:ext cx="4267200" cy="2794000"/>
+            <a:off x="2907873" y="2939581"/>
+            <a:ext cx="393785" cy="374522"/>
           </a:xfrm>
           <a:prstGeom prst="rect">
             <a:avLst/>
@@ -4878,6 +6313,454 @@
           </a:p>
         </p:txBody>
       </p:sp>
+      <p:sp>
+        <p:nvSpPr>
+          <p:cNvPr id="19" name="직사각형 18">
+            <a:extLst>
+              <a:ext uri="{FF2B5EF4-FFF2-40B4-BE49-F238E27FC236}">
+                <a16:creationId xmlns:a16="http://schemas.microsoft.com/office/drawing/2014/main" id="{EAF2268F-DD14-F6AC-5591-EE18A573C4A0}"/>
+              </a:ext>
+            </a:extLst>
+          </p:cNvPr>
+          <p:cNvSpPr/>
+          <p:nvPr/>
+        </p:nvSpPr>
+        <p:spPr>
+          <a:xfrm>
+            <a:off x="4038600" y="2939581"/>
+            <a:ext cx="393785" cy="374522"/>
+          </a:xfrm>
+          <a:prstGeom prst="rect">
+            <a:avLst/>
+          </a:prstGeom>
+          <a:noFill/>
+          <a:ln w="28575" cap="flat" cmpd="sng" algn="ctr">
+            <a:solidFill>
+              <a:srgbClr val="FF0000"/>
+            </a:solidFill>
+            <a:prstDash val="solid"/>
+            <a:miter lim="800000"/>
+          </a:ln>
+          <a:effectLst/>
+          <a:extLst>
+            <a:ext uri="{909E8E84-426E-40DD-AFC4-6F175D3DCCD1}">
+              <a14:hiddenFill xmlns:a14="http://schemas.microsoft.com/office/drawing/2010/main">
+                <a:solidFill>
+                  <a:schemeClr val="accent1"/>
+                </a:solidFill>
+              </a14:hiddenFill>
+            </a:ext>
+          </a:extLst>
+        </p:spPr>
+        <p:style>
+          <a:lnRef idx="2">
+            <a:schemeClr val="accent1">
+              <a:shade val="15000"/>
+            </a:schemeClr>
+          </a:lnRef>
+          <a:fillRef idx="1">
+            <a:schemeClr val="accent1"/>
+          </a:fillRef>
+          <a:effectRef idx="0">
+            <a:schemeClr val="accent1"/>
+          </a:effectRef>
+          <a:fontRef idx="minor">
+            <a:schemeClr val="lt1"/>
+          </a:fontRef>
+        </p:style>
+        <p:txBody>
+          <a:bodyPr rtlCol="0" anchor="ctr"/>
+          <a:lstStyle/>
+          <a:p>
+            <a:pPr algn="ctr"/>
+            <a:endParaRPr lang="ko-KR" altLang="en-US"/>
+          </a:p>
+        </p:txBody>
+      </p:sp>
+      <p:sp>
+        <p:nvSpPr>
+          <p:cNvPr id="20" name="직사각형 19">
+            <a:extLst>
+              <a:ext uri="{FF2B5EF4-FFF2-40B4-BE49-F238E27FC236}">
+                <a16:creationId xmlns:a16="http://schemas.microsoft.com/office/drawing/2014/main" id="{64CFCCCA-1517-7AFC-5087-60AE131047DB}"/>
+              </a:ext>
+            </a:extLst>
+          </p:cNvPr>
+          <p:cNvSpPr/>
+          <p:nvPr/>
+        </p:nvSpPr>
+        <p:spPr>
+          <a:xfrm>
+            <a:off x="5169327" y="2968731"/>
+            <a:ext cx="393785" cy="374522"/>
+          </a:xfrm>
+          <a:prstGeom prst="rect">
+            <a:avLst/>
+          </a:prstGeom>
+          <a:noFill/>
+          <a:ln w="28575" cap="flat" cmpd="sng" algn="ctr">
+            <a:solidFill>
+              <a:srgbClr val="FF0000"/>
+            </a:solidFill>
+            <a:prstDash val="solid"/>
+            <a:miter lim="800000"/>
+          </a:ln>
+          <a:effectLst/>
+          <a:extLst>
+            <a:ext uri="{909E8E84-426E-40DD-AFC4-6F175D3DCCD1}">
+              <a14:hiddenFill xmlns:a14="http://schemas.microsoft.com/office/drawing/2010/main">
+                <a:solidFill>
+                  <a:schemeClr val="accent1"/>
+                </a:solidFill>
+              </a14:hiddenFill>
+            </a:ext>
+          </a:extLst>
+        </p:spPr>
+        <p:style>
+          <a:lnRef idx="2">
+            <a:schemeClr val="accent1">
+              <a:shade val="15000"/>
+            </a:schemeClr>
+          </a:lnRef>
+          <a:fillRef idx="1">
+            <a:schemeClr val="accent1"/>
+          </a:fillRef>
+          <a:effectRef idx="0">
+            <a:schemeClr val="accent1"/>
+          </a:effectRef>
+          <a:fontRef idx="minor">
+            <a:schemeClr val="lt1"/>
+          </a:fontRef>
+        </p:style>
+        <p:txBody>
+          <a:bodyPr rtlCol="0" anchor="ctr"/>
+          <a:lstStyle/>
+          <a:p>
+            <a:pPr algn="ctr"/>
+            <a:endParaRPr lang="ko-KR" altLang="en-US"/>
+          </a:p>
+        </p:txBody>
+      </p:sp>
+      <p:sp>
+        <p:nvSpPr>
+          <p:cNvPr id="21" name="직사각형 20">
+            <a:extLst>
+              <a:ext uri="{FF2B5EF4-FFF2-40B4-BE49-F238E27FC236}">
+                <a16:creationId xmlns:a16="http://schemas.microsoft.com/office/drawing/2014/main" id="{ABE202F9-DD17-A165-1BD0-5D7C5F7370DD}"/>
+              </a:ext>
+            </a:extLst>
+          </p:cNvPr>
+          <p:cNvSpPr/>
+          <p:nvPr/>
+        </p:nvSpPr>
+        <p:spPr>
+          <a:xfrm>
+            <a:off x="6300054" y="2968731"/>
+            <a:ext cx="393785" cy="374522"/>
+          </a:xfrm>
+          <a:prstGeom prst="rect">
+            <a:avLst/>
+          </a:prstGeom>
+          <a:noFill/>
+          <a:ln w="28575" cap="flat" cmpd="sng" algn="ctr">
+            <a:solidFill>
+              <a:srgbClr val="FF0000"/>
+            </a:solidFill>
+            <a:prstDash val="solid"/>
+            <a:miter lim="800000"/>
+          </a:ln>
+          <a:effectLst/>
+          <a:extLst>
+            <a:ext uri="{909E8E84-426E-40DD-AFC4-6F175D3DCCD1}">
+              <a14:hiddenFill xmlns:a14="http://schemas.microsoft.com/office/drawing/2010/main">
+                <a:solidFill>
+                  <a:schemeClr val="accent1"/>
+                </a:solidFill>
+              </a14:hiddenFill>
+            </a:ext>
+          </a:extLst>
+        </p:spPr>
+        <p:style>
+          <a:lnRef idx="2">
+            <a:schemeClr val="accent1">
+              <a:shade val="15000"/>
+            </a:schemeClr>
+          </a:lnRef>
+          <a:fillRef idx="1">
+            <a:schemeClr val="accent1"/>
+          </a:fillRef>
+          <a:effectRef idx="0">
+            <a:schemeClr val="accent1"/>
+          </a:effectRef>
+          <a:fontRef idx="minor">
+            <a:schemeClr val="lt1"/>
+          </a:fontRef>
+        </p:style>
+        <p:txBody>
+          <a:bodyPr rtlCol="0" anchor="ctr"/>
+          <a:lstStyle/>
+          <a:p>
+            <a:pPr algn="ctr"/>
+            <a:endParaRPr lang="ko-KR" altLang="en-US"/>
+          </a:p>
+        </p:txBody>
+      </p:sp>
+      <p:sp>
+        <p:nvSpPr>
+          <p:cNvPr id="22" name="직사각형 21">
+            <a:extLst>
+              <a:ext uri="{FF2B5EF4-FFF2-40B4-BE49-F238E27FC236}">
+                <a16:creationId xmlns:a16="http://schemas.microsoft.com/office/drawing/2014/main" id="{6BF88ECA-FD6C-327F-4EE2-3C656FFE184C}"/>
+              </a:ext>
+            </a:extLst>
+          </p:cNvPr>
+          <p:cNvSpPr/>
+          <p:nvPr/>
+        </p:nvSpPr>
+        <p:spPr>
+          <a:xfrm>
+            <a:off x="3104765" y="3441103"/>
+            <a:ext cx="393785" cy="374522"/>
+          </a:xfrm>
+          <a:prstGeom prst="rect">
+            <a:avLst/>
+          </a:prstGeom>
+          <a:noFill/>
+          <a:ln w="28575" cap="flat" cmpd="sng" algn="ctr">
+            <a:solidFill>
+              <a:srgbClr val="FF0000"/>
+            </a:solidFill>
+            <a:prstDash val="solid"/>
+            <a:miter lim="800000"/>
+          </a:ln>
+          <a:effectLst/>
+          <a:extLst>
+            <a:ext uri="{909E8E84-426E-40DD-AFC4-6F175D3DCCD1}">
+              <a14:hiddenFill xmlns:a14="http://schemas.microsoft.com/office/drawing/2010/main">
+                <a:solidFill>
+                  <a:schemeClr val="accent1"/>
+                </a:solidFill>
+              </a14:hiddenFill>
+            </a:ext>
+          </a:extLst>
+        </p:spPr>
+        <p:style>
+          <a:lnRef idx="2">
+            <a:schemeClr val="accent1">
+              <a:shade val="15000"/>
+            </a:schemeClr>
+          </a:lnRef>
+          <a:fillRef idx="1">
+            <a:schemeClr val="accent1"/>
+          </a:fillRef>
+          <a:effectRef idx="0">
+            <a:schemeClr val="accent1"/>
+          </a:effectRef>
+          <a:fontRef idx="minor">
+            <a:schemeClr val="lt1"/>
+          </a:fontRef>
+        </p:style>
+        <p:txBody>
+          <a:bodyPr rtlCol="0" anchor="ctr"/>
+          <a:lstStyle/>
+          <a:p>
+            <a:pPr algn="ctr"/>
+            <a:endParaRPr lang="ko-KR" altLang="en-US"/>
+          </a:p>
+        </p:txBody>
+      </p:sp>
+      <p:sp>
+        <p:nvSpPr>
+          <p:cNvPr id="23" name="직사각형 22">
+            <a:extLst>
+              <a:ext uri="{FF2B5EF4-FFF2-40B4-BE49-F238E27FC236}">
+                <a16:creationId xmlns:a16="http://schemas.microsoft.com/office/drawing/2014/main" id="{4B43F2E7-74C3-652F-A6F2-1987F151F2FC}"/>
+              </a:ext>
+            </a:extLst>
+          </p:cNvPr>
+          <p:cNvSpPr/>
+          <p:nvPr/>
+        </p:nvSpPr>
+        <p:spPr>
+          <a:xfrm>
+            <a:off x="4235492" y="3441103"/>
+            <a:ext cx="393785" cy="374522"/>
+          </a:xfrm>
+          <a:prstGeom prst="rect">
+            <a:avLst/>
+          </a:prstGeom>
+          <a:noFill/>
+          <a:ln w="28575" cap="flat" cmpd="sng" algn="ctr">
+            <a:solidFill>
+              <a:srgbClr val="FF0000"/>
+            </a:solidFill>
+            <a:prstDash val="solid"/>
+            <a:miter lim="800000"/>
+          </a:ln>
+          <a:effectLst/>
+          <a:extLst>
+            <a:ext uri="{909E8E84-426E-40DD-AFC4-6F175D3DCCD1}">
+              <a14:hiddenFill xmlns:a14="http://schemas.microsoft.com/office/drawing/2010/main">
+                <a:solidFill>
+                  <a:schemeClr val="accent1"/>
+                </a:solidFill>
+              </a14:hiddenFill>
+            </a:ext>
+          </a:extLst>
+        </p:spPr>
+        <p:style>
+          <a:lnRef idx="2">
+            <a:schemeClr val="accent1">
+              <a:shade val="15000"/>
+            </a:schemeClr>
+          </a:lnRef>
+          <a:fillRef idx="1">
+            <a:schemeClr val="accent1"/>
+          </a:fillRef>
+          <a:effectRef idx="0">
+            <a:schemeClr val="accent1"/>
+          </a:effectRef>
+          <a:fontRef idx="minor">
+            <a:schemeClr val="lt1"/>
+          </a:fontRef>
+        </p:style>
+        <p:txBody>
+          <a:bodyPr rtlCol="0" anchor="ctr"/>
+          <a:lstStyle/>
+          <a:p>
+            <a:pPr algn="ctr"/>
+            <a:endParaRPr lang="ko-KR" altLang="en-US"/>
+          </a:p>
+        </p:txBody>
+      </p:sp>
+      <p:sp>
+        <p:nvSpPr>
+          <p:cNvPr id="26" name="직사각형 25">
+            <a:extLst>
+              <a:ext uri="{FF2B5EF4-FFF2-40B4-BE49-F238E27FC236}">
+                <a16:creationId xmlns:a16="http://schemas.microsoft.com/office/drawing/2014/main" id="{8C07FE70-E5D3-A81A-655B-FC094349E3CC}"/>
+              </a:ext>
+            </a:extLst>
+          </p:cNvPr>
+          <p:cNvSpPr/>
+          <p:nvPr/>
+        </p:nvSpPr>
+        <p:spPr>
+          <a:xfrm>
+            <a:off x="5366219" y="3441103"/>
+            <a:ext cx="393785" cy="374522"/>
+          </a:xfrm>
+          <a:prstGeom prst="rect">
+            <a:avLst/>
+          </a:prstGeom>
+          <a:noFill/>
+          <a:ln w="28575" cap="flat" cmpd="sng" algn="ctr">
+            <a:solidFill>
+              <a:srgbClr val="FF0000"/>
+            </a:solidFill>
+            <a:prstDash val="solid"/>
+            <a:miter lim="800000"/>
+          </a:ln>
+          <a:effectLst/>
+          <a:extLst>
+            <a:ext uri="{909E8E84-426E-40DD-AFC4-6F175D3DCCD1}">
+              <a14:hiddenFill xmlns:a14="http://schemas.microsoft.com/office/drawing/2010/main">
+                <a:solidFill>
+                  <a:schemeClr val="accent1"/>
+                </a:solidFill>
+              </a14:hiddenFill>
+            </a:ext>
+          </a:extLst>
+        </p:spPr>
+        <p:style>
+          <a:lnRef idx="2">
+            <a:schemeClr val="accent1">
+              <a:shade val="15000"/>
+            </a:schemeClr>
+          </a:lnRef>
+          <a:fillRef idx="1">
+            <a:schemeClr val="accent1"/>
+          </a:fillRef>
+          <a:effectRef idx="0">
+            <a:schemeClr val="accent1"/>
+          </a:effectRef>
+          <a:fontRef idx="minor">
+            <a:schemeClr val="lt1"/>
+          </a:fontRef>
+        </p:style>
+        <p:txBody>
+          <a:bodyPr rtlCol="0" anchor="ctr"/>
+          <a:lstStyle/>
+          <a:p>
+            <a:pPr algn="ctr"/>
+            <a:endParaRPr lang="ko-KR" altLang="en-US"/>
+          </a:p>
+        </p:txBody>
+      </p:sp>
+      <p:sp>
+        <p:nvSpPr>
+          <p:cNvPr id="27" name="직사각형 26">
+            <a:extLst>
+              <a:ext uri="{FF2B5EF4-FFF2-40B4-BE49-F238E27FC236}">
+                <a16:creationId xmlns:a16="http://schemas.microsoft.com/office/drawing/2014/main" id="{75518DDC-C472-F4E9-0EF5-1D9547A9D5DC}"/>
+              </a:ext>
+            </a:extLst>
+          </p:cNvPr>
+          <p:cNvSpPr/>
+          <p:nvPr/>
+        </p:nvSpPr>
+        <p:spPr>
+          <a:xfrm>
+            <a:off x="6496946" y="3441103"/>
+            <a:ext cx="393785" cy="374522"/>
+          </a:xfrm>
+          <a:prstGeom prst="rect">
+            <a:avLst/>
+          </a:prstGeom>
+          <a:noFill/>
+          <a:ln w="28575" cap="flat" cmpd="sng" algn="ctr">
+            <a:solidFill>
+              <a:srgbClr val="FF0000"/>
+            </a:solidFill>
+            <a:prstDash val="solid"/>
+            <a:miter lim="800000"/>
+          </a:ln>
+          <a:effectLst/>
+          <a:extLst>
+            <a:ext uri="{909E8E84-426E-40DD-AFC4-6F175D3DCCD1}">
+              <a14:hiddenFill xmlns:a14="http://schemas.microsoft.com/office/drawing/2010/main">
+                <a:solidFill>
+                  <a:schemeClr val="accent1"/>
+                </a:solidFill>
+              </a14:hiddenFill>
+            </a:ext>
+          </a:extLst>
+        </p:spPr>
+        <p:style>
+          <a:lnRef idx="2">
+            <a:schemeClr val="accent1">
+              <a:shade val="15000"/>
+            </a:schemeClr>
+          </a:lnRef>
+          <a:fillRef idx="1">
+            <a:schemeClr val="accent1"/>
+          </a:fillRef>
+          <a:effectRef idx="0">
+            <a:schemeClr val="accent1"/>
+          </a:effectRef>
+          <a:fontRef idx="minor">
+            <a:schemeClr val="lt1"/>
+          </a:fontRef>
+        </p:style>
+        <p:txBody>
+          <a:bodyPr rtlCol="0" anchor="ctr"/>
+          <a:lstStyle/>
+          <a:p>
+            <a:pPr algn="ctr"/>
+            <a:endParaRPr lang="ko-KR" altLang="en-US"/>
+          </a:p>
+        </p:txBody>
+      </p:sp>
       <p:cxnSp>
         <p:nvCxnSpPr>
           <p:cNvPr id="6" name="직선 연결선 5">
@@ -4887,13 +6770,15 @@
               </a:ext>
             </a:extLst>
           </p:cNvPr>
-          <p:cNvCxnSpPr/>
+          <p:cNvCxnSpPr>
+            <a:cxnSpLocks/>
+          </p:cNvCxnSpPr>
           <p:nvPr/>
         </p:nvCxnSpPr>
         <p:spPr>
-          <a:xfrm flipV="1">
-            <a:off x="6413500" y="1651000"/>
-            <a:ext cx="1841500" cy="1524000"/>
+          <a:xfrm flipH="1">
+            <a:off x="6923291" y="1912550"/>
+            <a:ext cx="1856416" cy="1330375"/>
           </a:xfrm>
           <a:prstGeom prst="line">
             <a:avLst/>
@@ -4922,10 +6807,10 @@
       </p:cxnSp>
       <p:sp>
         <p:nvSpPr>
-          <p:cNvPr id="7" name="사각형: 둥근 모서리 6">
-            <a:extLst>
-              <a:ext uri="{FF2B5EF4-FFF2-40B4-BE49-F238E27FC236}">
-                <a16:creationId xmlns:a16="http://schemas.microsoft.com/office/drawing/2014/main" id="{08A83FA5-B3EA-B3EE-7545-F7A4153B2AEF}"/>
+          <p:cNvPr id="29" name="직사각형 28">
+            <a:extLst>
+              <a:ext uri="{FF2B5EF4-FFF2-40B4-BE49-F238E27FC236}">
+                <a16:creationId xmlns:a16="http://schemas.microsoft.com/office/drawing/2014/main" id="{2372A897-E6A5-A149-DAC2-763EB5324F2D}"/>
               </a:ext>
             </a:extLst>
           </p:cNvPr>
@@ -4934,20 +6819,30 @@
         </p:nvSpPr>
         <p:spPr>
           <a:xfrm>
-            <a:off x="7937500" y="1041400"/>
-            <a:ext cx="3619500" cy="1549400"/>
-          </a:xfrm>
-          <a:prstGeom prst="roundRect">
+            <a:off x="6603318" y="4737696"/>
+            <a:ext cx="1549028" cy="257751"/>
+          </a:xfrm>
+          <a:prstGeom prst="rect">
             <a:avLst/>
           </a:prstGeom>
-          <a:solidFill>
-            <a:srgbClr val="ECF9FF"/>
-          </a:solidFill>
-          <a:ln w="15875">
+          <a:noFill/>
+          <a:ln w="28575" cap="flat" cmpd="sng" algn="ctr">
             <a:solidFill>
-              <a:srgbClr val="ADADAD"/>
+              <a:srgbClr val="FF0000"/>
             </a:solidFill>
+            <a:prstDash val="solid"/>
+            <a:miter lim="800000"/>
           </a:ln>
+          <a:effectLst/>
+          <a:extLst>
+            <a:ext uri="{909E8E84-426E-40DD-AFC4-6F175D3DCCD1}">
+              <a14:hiddenFill xmlns:a14="http://schemas.microsoft.com/office/drawing/2010/main">
+                <a:solidFill>
+                  <a:schemeClr val="accent1"/>
+                </a:solidFill>
+              </a14:hiddenFill>
+            </a:ext>
+          </a:extLst>
         </p:spPr>
         <p:style>
           <a:lnRef idx="2">
@@ -4966,750 +6861,11 @@
           </a:fontRef>
         </p:style>
         <p:txBody>
-          <a:bodyPr lIns="101600" tIns="63500" rIns="101600" bIns="63500" rtlCol="0" anchor="ctr"/>
+          <a:bodyPr rtlCol="0" anchor="ctr"/>
           <a:lstStyle/>
           <a:p>
             <a:pPr algn="ctr"/>
-            <a:r>
-              <a:rPr lang="en-US" altLang="ko-KR" sz="1200">
-                <a:solidFill>
-                  <a:srgbClr val="000000"/>
-                </a:solidFill>
-                <a:latin typeface="Malgun Gothic" panose="020B0503020000020004" pitchFamily="50" charset="-127"/>
-              </a:rPr>
-              <a:t>AR/R </a:t>
-            </a:r>
-            <a:r>
-              <a:rPr lang="ko-KR" altLang="en-US" sz="1200">
-                <a:solidFill>
-                  <a:srgbClr val="000000"/>
-                </a:solidFill>
-                <a:latin typeface="Malgun Gothic" panose="020B0503020000020004" pitchFamily="50" charset="-127"/>
-              </a:rPr>
-              <a:t>채널 </a:t>
-            </a:r>
-            <a:r>
-              <a:rPr lang="en-US" altLang="ko-KR" sz="1200">
-                <a:solidFill>
-                  <a:srgbClr val="000000"/>
-                </a:solidFill>
-                <a:latin typeface="Malgun Gothic" panose="020B0503020000020004" pitchFamily="50" charset="-127"/>
-              </a:rPr>
-              <a:t>handshake:</a:t>
-            </a:r>
-          </a:p>
-          <a:p>
-            <a:pPr algn="ctr"/>
-            <a:r>
-              <a:rPr lang="en-US" altLang="ko-KR" sz="1200">
-                <a:solidFill>
-                  <a:srgbClr val="000000"/>
-                </a:solidFill>
-                <a:latin typeface="Malgun Gothic" panose="020B0503020000020004" pitchFamily="50" charset="-127"/>
-              </a:rPr>
-              <a:t>ARVALID-ARREADY: read </a:t>
-            </a:r>
-            <a:r>
-              <a:rPr lang="ko-KR" altLang="en-US" sz="1200">
-                <a:solidFill>
-                  <a:srgbClr val="000000"/>
-                </a:solidFill>
-                <a:latin typeface="Malgun Gothic" panose="020B0503020000020004" pitchFamily="50" charset="-127"/>
-              </a:rPr>
-              <a:t>주소 수락</a:t>
-            </a:r>
-          </a:p>
-          <a:p>
-            <a:pPr algn="ctr"/>
-            <a:r>
-              <a:rPr lang="en-US" altLang="ko-KR" sz="1200">
-                <a:solidFill>
-                  <a:srgbClr val="000000"/>
-                </a:solidFill>
-                <a:latin typeface="Malgun Gothic" panose="020B0503020000020004" pitchFamily="50" charset="-127"/>
-              </a:rPr>
-              <a:t>RVALID-RREADY: read data phase </a:t>
-            </a:r>
-            <a:r>
-              <a:rPr lang="ko-KR" altLang="en-US" sz="1200">
-                <a:solidFill>
-                  <a:srgbClr val="000000"/>
-                </a:solidFill>
-                <a:latin typeface="Malgun Gothic" panose="020B0503020000020004" pitchFamily="50" charset="-127"/>
-              </a:rPr>
-              <a:t>완료</a:t>
-            </a:r>
-          </a:p>
-          <a:p>
-            <a:pPr algn="ctr"/>
-            <a:r>
-              <a:rPr lang="en-US" altLang="ko-KR" sz="1200">
-                <a:solidFill>
-                  <a:srgbClr val="000000"/>
-                </a:solidFill>
-                <a:latin typeface="Malgun Gothic" panose="020B0503020000020004" pitchFamily="50" charset="-127"/>
-              </a:rPr>
-              <a:t>RRESP=0: OKAY </a:t>
-            </a:r>
-            <a:r>
-              <a:rPr lang="ko-KR" altLang="en-US" sz="1200">
-                <a:solidFill>
-                  <a:srgbClr val="000000"/>
-                </a:solidFill>
-                <a:latin typeface="Malgun Gothic" panose="020B0503020000020004" pitchFamily="50" charset="-127"/>
-              </a:rPr>
-              <a:t>응답</a:t>
-            </a:r>
-          </a:p>
-        </p:txBody>
-      </p:sp>
-      <p:sp>
-        <p:nvSpPr>
-          <p:cNvPr id="8" name="사각형: 둥근 모서리 7">
-            <a:extLst>
-              <a:ext uri="{FF2B5EF4-FFF2-40B4-BE49-F238E27FC236}">
-                <a16:creationId xmlns:a16="http://schemas.microsoft.com/office/drawing/2014/main" id="{F83D7C12-9F50-9ECB-85D0-CE8680505232}"/>
-              </a:ext>
-            </a:extLst>
-          </p:cNvPr>
-          <p:cNvSpPr/>
-          <p:nvPr/>
-        </p:nvSpPr>
-        <p:spPr>
-          <a:xfrm>
-            <a:off x="7937500" y="2870200"/>
-            <a:ext cx="3619500" cy="1422400"/>
-          </a:xfrm>
-          <a:prstGeom prst="roundRect">
-            <a:avLst/>
-          </a:prstGeom>
-          <a:solidFill>
-            <a:srgbClr val="F2F2F2"/>
-          </a:solidFill>
-          <a:ln w="15875">
-            <a:solidFill>
-              <a:srgbClr val="FF0000"/>
-            </a:solidFill>
-          </a:ln>
-        </p:spPr>
-        <p:style>
-          <a:lnRef idx="2">
-            <a:schemeClr val="accent1">
-              <a:shade val="15000"/>
-            </a:schemeClr>
-          </a:lnRef>
-          <a:fillRef idx="1">
-            <a:schemeClr val="accent1"/>
-          </a:fillRef>
-          <a:effectRef idx="0">
-            <a:schemeClr val="accent1"/>
-          </a:effectRef>
-          <a:fontRef idx="minor">
-            <a:schemeClr val="lt1"/>
-          </a:fontRef>
-        </p:style>
-        <p:txBody>
-          <a:bodyPr lIns="101600" tIns="63500" rIns="101600" bIns="63500" rtlCol="0" anchor="ctr"/>
-          <a:lstStyle/>
-          <a:p>
-            <a:pPr algn="ctr"/>
-            <a:r>
-              <a:rPr lang="en-US" altLang="ko-KR" sz="1200">
-                <a:solidFill>
-                  <a:srgbClr val="000000"/>
-                </a:solidFill>
-                <a:latin typeface="Malgun Gothic" panose="020B0503020000020004" pitchFamily="50" charset="-127"/>
-              </a:rPr>
-              <a:t>ARADDR </a:t>
-            </a:r>
-            <a:r>
-              <a:rPr lang="ko-KR" altLang="en-US" sz="1200">
-                <a:solidFill>
-                  <a:srgbClr val="000000"/>
-                </a:solidFill>
-                <a:latin typeface="Malgun Gothic" panose="020B0503020000020004" pitchFamily="50" charset="-127"/>
-              </a:rPr>
-              <a:t>요청 순서와 </a:t>
-            </a:r>
-            <a:r>
-              <a:rPr lang="en-US" altLang="ko-KR" sz="1200">
-                <a:solidFill>
-                  <a:srgbClr val="000000"/>
-                </a:solidFill>
-                <a:latin typeface="Malgun Gothic" panose="020B0503020000020004" pitchFamily="50" charset="-127"/>
-              </a:rPr>
-              <a:t>RDATA </a:t>
-            </a:r>
-            <a:r>
-              <a:rPr lang="ko-KR" altLang="en-US" sz="1200">
-                <a:solidFill>
-                  <a:srgbClr val="000000"/>
-                </a:solidFill>
-                <a:latin typeface="Malgun Gothic" panose="020B0503020000020004" pitchFamily="50" charset="-127"/>
-              </a:rPr>
-              <a:t>반환 순서가 </a:t>
-            </a:r>
-            <a:r>
-              <a:rPr lang="en-US" altLang="ko-KR" sz="1200">
-                <a:solidFill>
-                  <a:srgbClr val="000000"/>
-                </a:solidFill>
-                <a:latin typeface="Malgun Gothic" panose="020B0503020000020004" pitchFamily="50" charset="-127"/>
-              </a:rPr>
-              <a:t>write </a:t>
-            </a:r>
-            <a:r>
-              <a:rPr lang="ko-KR" altLang="en-US" sz="1200">
-                <a:solidFill>
-                  <a:srgbClr val="000000"/>
-                </a:solidFill>
-                <a:latin typeface="Malgun Gothic" panose="020B0503020000020004" pitchFamily="50" charset="-127"/>
-              </a:rPr>
-              <a:t>때 저장한 값과 일치한다</a:t>
-            </a:r>
-            <a:r>
-              <a:rPr lang="en-US" altLang="ko-KR" sz="1200">
-                <a:solidFill>
-                  <a:srgbClr val="000000"/>
-                </a:solidFill>
-                <a:latin typeface="Malgun Gothic" panose="020B0503020000020004" pitchFamily="50" charset="-127"/>
-              </a:rPr>
-              <a:t>. </a:t>
-            </a:r>
-            <a:r>
-              <a:rPr lang="ko-KR" altLang="en-US" sz="1200">
-                <a:solidFill>
-                  <a:srgbClr val="000000"/>
-                </a:solidFill>
-                <a:latin typeface="Malgun Gothic" panose="020B0503020000020004" pitchFamily="50" charset="-127"/>
-              </a:rPr>
-              <a:t>마지막 </a:t>
-            </a:r>
-            <a:r>
-              <a:rPr lang="en-US" altLang="ko-KR" sz="1200">
-                <a:solidFill>
-                  <a:srgbClr val="000000"/>
-                </a:solidFill>
-                <a:latin typeface="Malgun Gothic" panose="020B0503020000020004" pitchFamily="50" charset="-127"/>
-              </a:rPr>
-              <a:t>read</a:t>
-            </a:r>
-            <a:r>
-              <a:rPr lang="ko-KR" altLang="en-US" sz="1200">
-                <a:solidFill>
-                  <a:srgbClr val="000000"/>
-                </a:solidFill>
-                <a:latin typeface="Malgun Gothic" panose="020B0503020000020004" pitchFamily="50" charset="-127"/>
-              </a:rPr>
-              <a:t>에서는 </a:t>
-            </a:r>
-            <a:r>
-              <a:rPr lang="en-US" altLang="ko-KR" sz="1200">
-                <a:solidFill>
-                  <a:srgbClr val="000000"/>
-                </a:solidFill>
-                <a:latin typeface="Malgun Gothic" panose="020B0503020000020004" pitchFamily="50" charset="-127"/>
-              </a:rPr>
-              <a:t>RDATA=44444444</a:t>
-            </a:r>
-            <a:r>
-              <a:rPr lang="ko-KR" altLang="en-US" sz="1200">
-                <a:solidFill>
-                  <a:srgbClr val="000000"/>
-                </a:solidFill>
-                <a:latin typeface="Malgun Gothic" panose="020B0503020000020004" pitchFamily="50" charset="-127"/>
-              </a:rPr>
-              <a:t>가 관측되어 </a:t>
-            </a:r>
-            <a:r>
-              <a:rPr lang="en-US" altLang="ko-KR" sz="1200">
-                <a:solidFill>
-                  <a:srgbClr val="000000"/>
-                </a:solidFill>
-                <a:latin typeface="Malgun Gothic" panose="020B0503020000020004" pitchFamily="50" charset="-127"/>
-              </a:rPr>
-              <a:t>slv_reg3 readback</a:t>
-            </a:r>
-            <a:r>
-              <a:rPr lang="ko-KR" altLang="en-US" sz="1200">
-                <a:solidFill>
-                  <a:srgbClr val="000000"/>
-                </a:solidFill>
-                <a:latin typeface="Malgun Gothic" panose="020B0503020000020004" pitchFamily="50" charset="-127"/>
-              </a:rPr>
-              <a:t>이 정상임을 확인한다</a:t>
-            </a:r>
-            <a:r>
-              <a:rPr lang="en-US" altLang="ko-KR" sz="1200">
-                <a:solidFill>
-                  <a:srgbClr val="000000"/>
-                </a:solidFill>
-                <a:latin typeface="Malgun Gothic" panose="020B0503020000020004" pitchFamily="50" charset="-127"/>
-              </a:rPr>
-              <a:t>.</a:t>
-            </a:r>
-            <a:endParaRPr lang="ko-KR" altLang="en-US" sz="1200">
-              <a:solidFill>
-                <a:srgbClr val="000000"/>
-              </a:solidFill>
-              <a:latin typeface="Malgun Gothic" panose="020B0503020000020004" pitchFamily="50" charset="-127"/>
-            </a:endParaRPr>
-          </a:p>
-        </p:txBody>
-      </p:sp>
-      <p:sp>
-        <p:nvSpPr>
-          <p:cNvPr id="9" name="사각형: 둥근 모서리 8">
-            <a:extLst>
-              <a:ext uri="{FF2B5EF4-FFF2-40B4-BE49-F238E27FC236}">
-                <a16:creationId xmlns:a16="http://schemas.microsoft.com/office/drawing/2014/main" id="{310A6073-53A1-ABBB-1C4B-04E424A8FBD0}"/>
-              </a:ext>
-            </a:extLst>
-          </p:cNvPr>
-          <p:cNvSpPr/>
-          <p:nvPr/>
-        </p:nvSpPr>
-        <p:spPr>
-          <a:xfrm>
-            <a:off x="1473200" y="5943600"/>
-            <a:ext cx="1168400" cy="279400"/>
-          </a:xfrm>
-          <a:prstGeom prst="roundRect">
-            <a:avLst/>
-          </a:prstGeom>
-          <a:solidFill>
-            <a:srgbClr val="0070C0"/>
-          </a:solidFill>
-          <a:ln>
-            <a:solidFill>
-              <a:srgbClr val="0070C0"/>
-            </a:solidFill>
-          </a:ln>
-        </p:spPr>
-        <p:style>
-          <a:lnRef idx="2">
-            <a:schemeClr val="accent1">
-              <a:shade val="15000"/>
-            </a:schemeClr>
-          </a:lnRef>
-          <a:fillRef idx="1">
-            <a:schemeClr val="accent1"/>
-          </a:fillRef>
-          <a:effectRef idx="0">
-            <a:schemeClr val="accent1"/>
-          </a:effectRef>
-          <a:fontRef idx="minor">
-            <a:schemeClr val="lt1"/>
-          </a:fontRef>
-        </p:style>
-        <p:txBody>
-          <a:bodyPr lIns="50800" tIns="12700" rIns="50800" bIns="12700" rtlCol="0" anchor="ctr"/>
-          <a:lstStyle/>
-          <a:p>
-            <a:pPr algn="ctr"/>
-            <a:r>
-              <a:rPr lang="en-US" altLang="ko-KR" sz="1100" b="1">
-                <a:solidFill>
-                  <a:srgbClr val="FFFFFF"/>
-                </a:solidFill>
-                <a:latin typeface="Malgun Gothic" panose="020B0503020000020004" pitchFamily="50" charset="-127"/>
-              </a:rPr>
-              <a:t>286 ns</a:t>
-            </a:r>
-            <a:endParaRPr lang="ko-KR" altLang="en-US" sz="1100" b="1">
-              <a:solidFill>
-                <a:srgbClr val="FFFFFF"/>
-              </a:solidFill>
-              <a:latin typeface="Malgun Gothic" panose="020B0503020000020004" pitchFamily="50" charset="-127"/>
-            </a:endParaRPr>
-          </a:p>
-        </p:txBody>
-      </p:sp>
-      <p:sp>
-        <p:nvSpPr>
-          <p:cNvPr id="10" name="사각형: 둥근 모서리 9">
-            <a:extLst>
-              <a:ext uri="{FF2B5EF4-FFF2-40B4-BE49-F238E27FC236}">
-                <a16:creationId xmlns:a16="http://schemas.microsoft.com/office/drawing/2014/main" id="{61F86DF5-4D11-8DED-EA31-59E81E1CBCBA}"/>
-              </a:ext>
-            </a:extLst>
-          </p:cNvPr>
-          <p:cNvSpPr/>
-          <p:nvPr/>
-        </p:nvSpPr>
-        <p:spPr>
-          <a:xfrm>
-            <a:off x="2870200" y="5943600"/>
-            <a:ext cx="1168400" cy="279400"/>
-          </a:xfrm>
-          <a:prstGeom prst="roundRect">
-            <a:avLst/>
-          </a:prstGeom>
-          <a:solidFill>
-            <a:srgbClr val="0070C0"/>
-          </a:solidFill>
-          <a:ln>
-            <a:solidFill>
-              <a:srgbClr val="0070C0"/>
-            </a:solidFill>
-          </a:ln>
-        </p:spPr>
-        <p:style>
-          <a:lnRef idx="2">
-            <a:schemeClr val="accent1">
-              <a:shade val="15000"/>
-            </a:schemeClr>
-          </a:lnRef>
-          <a:fillRef idx="1">
-            <a:schemeClr val="accent1"/>
-          </a:fillRef>
-          <a:effectRef idx="0">
-            <a:schemeClr val="accent1"/>
-          </a:effectRef>
-          <a:fontRef idx="minor">
-            <a:schemeClr val="lt1"/>
-          </a:fontRef>
-        </p:style>
-        <p:txBody>
-          <a:bodyPr lIns="50800" tIns="12700" rIns="50800" bIns="12700" rtlCol="0" anchor="ctr"/>
-          <a:lstStyle/>
-          <a:p>
-            <a:pPr algn="ctr"/>
-            <a:r>
-              <a:rPr lang="en-US" altLang="ko-KR" sz="1100" b="1">
-                <a:solidFill>
-                  <a:srgbClr val="FFFFFF"/>
-                </a:solidFill>
-                <a:latin typeface="Malgun Gothic" panose="020B0503020000020004" pitchFamily="50" charset="-127"/>
-              </a:rPr>
-              <a:t>336 ns</a:t>
-            </a:r>
-            <a:endParaRPr lang="ko-KR" altLang="en-US" sz="1100" b="1">
-              <a:solidFill>
-                <a:srgbClr val="FFFFFF"/>
-              </a:solidFill>
-              <a:latin typeface="Malgun Gothic" panose="020B0503020000020004" pitchFamily="50" charset="-127"/>
-            </a:endParaRPr>
-          </a:p>
-        </p:txBody>
-      </p:sp>
-      <p:sp>
-        <p:nvSpPr>
-          <p:cNvPr id="11" name="사각형: 둥근 모서리 10">
-            <a:extLst>
-              <a:ext uri="{FF2B5EF4-FFF2-40B4-BE49-F238E27FC236}">
-                <a16:creationId xmlns:a16="http://schemas.microsoft.com/office/drawing/2014/main" id="{F8C83E4C-199E-EDBC-BEFE-85E542B7113A}"/>
-              </a:ext>
-            </a:extLst>
-          </p:cNvPr>
-          <p:cNvSpPr/>
-          <p:nvPr/>
-        </p:nvSpPr>
-        <p:spPr>
-          <a:xfrm>
-            <a:off x="4279900" y="5943600"/>
-            <a:ext cx="1168400" cy="279400"/>
-          </a:xfrm>
-          <a:prstGeom prst="roundRect">
-            <a:avLst/>
-          </a:prstGeom>
-          <a:solidFill>
-            <a:srgbClr val="0070C0"/>
-          </a:solidFill>
-          <a:ln>
-            <a:solidFill>
-              <a:srgbClr val="0070C0"/>
-            </a:solidFill>
-          </a:ln>
-        </p:spPr>
-        <p:style>
-          <a:lnRef idx="2">
-            <a:schemeClr val="accent1">
-              <a:shade val="15000"/>
-            </a:schemeClr>
-          </a:lnRef>
-          <a:fillRef idx="1">
-            <a:schemeClr val="accent1"/>
-          </a:fillRef>
-          <a:effectRef idx="0">
-            <a:schemeClr val="accent1"/>
-          </a:effectRef>
-          <a:fontRef idx="minor">
-            <a:schemeClr val="lt1"/>
-          </a:fontRef>
-        </p:style>
-        <p:txBody>
-          <a:bodyPr lIns="50800" tIns="12700" rIns="50800" bIns="12700" rtlCol="0" anchor="ctr"/>
-          <a:lstStyle/>
-          <a:p>
-            <a:pPr algn="ctr"/>
-            <a:r>
-              <a:rPr lang="en-US" altLang="ko-KR" sz="1100" b="1">
-                <a:solidFill>
-                  <a:srgbClr val="FFFFFF"/>
-                </a:solidFill>
-                <a:latin typeface="Malgun Gothic" panose="020B0503020000020004" pitchFamily="50" charset="-127"/>
-              </a:rPr>
-              <a:t>386 ns</a:t>
-            </a:r>
-            <a:endParaRPr lang="ko-KR" altLang="en-US" sz="1100" b="1">
-              <a:solidFill>
-                <a:srgbClr val="FFFFFF"/>
-              </a:solidFill>
-              <a:latin typeface="Malgun Gothic" panose="020B0503020000020004" pitchFamily="50" charset="-127"/>
-            </a:endParaRPr>
-          </a:p>
-        </p:txBody>
-      </p:sp>
-      <p:sp>
-        <p:nvSpPr>
-          <p:cNvPr id="12" name="사각형: 둥근 모서리 11">
-            <a:extLst>
-              <a:ext uri="{FF2B5EF4-FFF2-40B4-BE49-F238E27FC236}">
-                <a16:creationId xmlns:a16="http://schemas.microsoft.com/office/drawing/2014/main" id="{66E4166A-146B-B18A-D260-2F1C592F51B4}"/>
-              </a:ext>
-            </a:extLst>
-          </p:cNvPr>
-          <p:cNvSpPr/>
-          <p:nvPr/>
-        </p:nvSpPr>
-        <p:spPr>
-          <a:xfrm>
-            <a:off x="5689600" y="5943600"/>
-            <a:ext cx="1168400" cy="279400"/>
-          </a:xfrm>
-          <a:prstGeom prst="roundRect">
-            <a:avLst/>
-          </a:prstGeom>
-          <a:solidFill>
-            <a:srgbClr val="0070C0"/>
-          </a:solidFill>
-          <a:ln>
-            <a:solidFill>
-              <a:srgbClr val="0070C0"/>
-            </a:solidFill>
-          </a:ln>
-        </p:spPr>
-        <p:style>
-          <a:lnRef idx="2">
-            <a:schemeClr val="accent1">
-              <a:shade val="15000"/>
-            </a:schemeClr>
-          </a:lnRef>
-          <a:fillRef idx="1">
-            <a:schemeClr val="accent1"/>
-          </a:fillRef>
-          <a:effectRef idx="0">
-            <a:schemeClr val="accent1"/>
-          </a:effectRef>
-          <a:fontRef idx="minor">
-            <a:schemeClr val="lt1"/>
-          </a:fontRef>
-        </p:style>
-        <p:txBody>
-          <a:bodyPr lIns="50800" tIns="12700" rIns="50800" bIns="12700" rtlCol="0" anchor="ctr"/>
-          <a:lstStyle/>
-          <a:p>
-            <a:pPr algn="ctr"/>
-            <a:r>
-              <a:rPr lang="en-US" altLang="ko-KR" sz="1100" b="1">
-                <a:solidFill>
-                  <a:srgbClr val="FFFFFF"/>
-                </a:solidFill>
-                <a:latin typeface="Malgun Gothic" panose="020B0503020000020004" pitchFamily="50" charset="-127"/>
-              </a:rPr>
-              <a:t>436 ns</a:t>
-            </a:r>
-            <a:endParaRPr lang="ko-KR" altLang="en-US" sz="1100" b="1">
-              <a:solidFill>
-                <a:srgbClr val="FFFFFF"/>
-              </a:solidFill>
-              <a:latin typeface="Malgun Gothic" panose="020B0503020000020004" pitchFamily="50" charset="-127"/>
-            </a:endParaRPr>
-          </a:p>
-        </p:txBody>
-      </p:sp>
-      <p:sp>
-        <p:nvSpPr>
-          <p:cNvPr id="13" name="TextBox 12">
-            <a:extLst>
-              <a:ext uri="{FF2B5EF4-FFF2-40B4-BE49-F238E27FC236}">
-                <a16:creationId xmlns:a16="http://schemas.microsoft.com/office/drawing/2014/main" id="{D24CDA76-80AE-6097-E4EC-C83C1D53A90A}"/>
-              </a:ext>
-            </a:extLst>
-          </p:cNvPr>
-          <p:cNvSpPr txBox="1"/>
-          <p:nvPr/>
-        </p:nvSpPr>
-        <p:spPr>
-          <a:xfrm>
-            <a:off x="1320800" y="6273800"/>
-            <a:ext cx="1473200" cy="205184"/>
-          </a:xfrm>
-          <a:prstGeom prst="rect">
-            <a:avLst/>
-          </a:prstGeom>
-          <a:noFill/>
-        </p:spPr>
-        <p:txBody>
-          <a:bodyPr vert="horz" lIns="63500" tIns="25400" rIns="63500" bIns="25400" rtlCol="0">
-            <a:spAutoFit/>
-          </a:bodyPr>
-          <a:lstStyle/>
-          <a:p>
-            <a:r>
-              <a:rPr lang="en-US" altLang="ko-KR" sz="1000">
-                <a:solidFill>
-                  <a:srgbClr val="000000"/>
-                </a:solidFill>
-                <a:latin typeface="Malgun Gothic" panose="020B0503020000020004" pitchFamily="50" charset="-127"/>
-              </a:rPr>
-              <a:t>0x00 -&gt; 11111111</a:t>
-            </a:r>
-            <a:endParaRPr lang="ko-KR" altLang="en-US" sz="1000">
-              <a:solidFill>
-                <a:srgbClr val="000000"/>
-              </a:solidFill>
-              <a:latin typeface="Malgun Gothic" panose="020B0503020000020004" pitchFamily="50" charset="-127"/>
-            </a:endParaRPr>
-          </a:p>
-        </p:txBody>
-      </p:sp>
-      <p:sp>
-        <p:nvSpPr>
-          <p:cNvPr id="14" name="TextBox 13">
-            <a:extLst>
-              <a:ext uri="{FF2B5EF4-FFF2-40B4-BE49-F238E27FC236}">
-                <a16:creationId xmlns:a16="http://schemas.microsoft.com/office/drawing/2014/main" id="{3DD46D91-A811-241C-5861-BE441C8B70AF}"/>
-              </a:ext>
-            </a:extLst>
-          </p:cNvPr>
-          <p:cNvSpPr txBox="1"/>
-          <p:nvPr/>
-        </p:nvSpPr>
-        <p:spPr>
-          <a:xfrm>
-            <a:off x="2717800" y="6273800"/>
-            <a:ext cx="1473200" cy="205184"/>
-          </a:xfrm>
-          <a:prstGeom prst="rect">
-            <a:avLst/>
-          </a:prstGeom>
-          <a:noFill/>
-        </p:spPr>
-        <p:txBody>
-          <a:bodyPr vert="horz" lIns="63500" tIns="25400" rIns="63500" bIns="25400" rtlCol="0">
-            <a:spAutoFit/>
-          </a:bodyPr>
-          <a:lstStyle/>
-          <a:p>
-            <a:r>
-              <a:rPr lang="en-US" altLang="ko-KR" sz="1000">
-                <a:solidFill>
-                  <a:srgbClr val="000000"/>
-                </a:solidFill>
-                <a:latin typeface="Malgun Gothic" panose="020B0503020000020004" pitchFamily="50" charset="-127"/>
-              </a:rPr>
-              <a:t>0x04 -&gt; 22222222</a:t>
-            </a:r>
-            <a:endParaRPr lang="ko-KR" altLang="en-US" sz="1000">
-              <a:solidFill>
-                <a:srgbClr val="000000"/>
-              </a:solidFill>
-              <a:latin typeface="Malgun Gothic" panose="020B0503020000020004" pitchFamily="50" charset="-127"/>
-            </a:endParaRPr>
-          </a:p>
-        </p:txBody>
-      </p:sp>
-      <p:sp>
-        <p:nvSpPr>
-          <p:cNvPr id="15" name="TextBox 14">
-            <a:extLst>
-              <a:ext uri="{FF2B5EF4-FFF2-40B4-BE49-F238E27FC236}">
-                <a16:creationId xmlns:a16="http://schemas.microsoft.com/office/drawing/2014/main" id="{46EAF054-3075-DE4A-6A5A-C0F69FD7AC66}"/>
-              </a:ext>
-            </a:extLst>
-          </p:cNvPr>
-          <p:cNvSpPr txBox="1"/>
-          <p:nvPr/>
-        </p:nvSpPr>
-        <p:spPr>
-          <a:xfrm>
-            <a:off x="4140200" y="6273800"/>
-            <a:ext cx="1473200" cy="205184"/>
-          </a:xfrm>
-          <a:prstGeom prst="rect">
-            <a:avLst/>
-          </a:prstGeom>
-          <a:noFill/>
-        </p:spPr>
-        <p:txBody>
-          <a:bodyPr vert="horz" lIns="63500" tIns="25400" rIns="63500" bIns="25400" rtlCol="0">
-            <a:spAutoFit/>
-          </a:bodyPr>
-          <a:lstStyle/>
-          <a:p>
-            <a:r>
-              <a:rPr lang="en-US" altLang="ko-KR" sz="1000">
-                <a:solidFill>
-                  <a:srgbClr val="000000"/>
-                </a:solidFill>
-                <a:latin typeface="Malgun Gothic" panose="020B0503020000020004" pitchFamily="50" charset="-127"/>
-              </a:rPr>
-              <a:t>0x08 -&gt; 33333333</a:t>
-            </a:r>
-            <a:endParaRPr lang="ko-KR" altLang="en-US" sz="1000">
-              <a:solidFill>
-                <a:srgbClr val="000000"/>
-              </a:solidFill>
-              <a:latin typeface="Malgun Gothic" panose="020B0503020000020004" pitchFamily="50" charset="-127"/>
-            </a:endParaRPr>
-          </a:p>
-        </p:txBody>
-      </p:sp>
-      <p:sp>
-        <p:nvSpPr>
-          <p:cNvPr id="16" name="TextBox 15">
-            <a:extLst>
-              <a:ext uri="{FF2B5EF4-FFF2-40B4-BE49-F238E27FC236}">
-                <a16:creationId xmlns:a16="http://schemas.microsoft.com/office/drawing/2014/main" id="{48830B1D-45AA-F360-7600-97353C6AB15C}"/>
-              </a:ext>
-            </a:extLst>
-          </p:cNvPr>
-          <p:cNvSpPr txBox="1"/>
-          <p:nvPr/>
-        </p:nvSpPr>
-        <p:spPr>
-          <a:xfrm>
-            <a:off x="5562600" y="6273800"/>
-            <a:ext cx="1473200" cy="205184"/>
-          </a:xfrm>
-          <a:prstGeom prst="rect">
-            <a:avLst/>
-          </a:prstGeom>
-          <a:noFill/>
-        </p:spPr>
-        <p:txBody>
-          <a:bodyPr vert="horz" lIns="63500" tIns="25400" rIns="63500" bIns="25400" rtlCol="0">
-            <a:spAutoFit/>
-          </a:bodyPr>
-          <a:lstStyle/>
-          <a:p>
-            <a:r>
-              <a:rPr lang="en-US" altLang="ko-KR" sz="1000">
-                <a:solidFill>
-                  <a:srgbClr val="000000"/>
-                </a:solidFill>
-                <a:latin typeface="Malgun Gothic" panose="020B0503020000020004" pitchFamily="50" charset="-127"/>
-              </a:rPr>
-              <a:t>0x0C -&gt; 44444444</a:t>
-            </a:r>
-            <a:endParaRPr lang="ko-KR" altLang="en-US" sz="1000">
-              <a:solidFill>
-                <a:srgbClr val="000000"/>
-              </a:solidFill>
-              <a:latin typeface="Malgun Gothic" panose="020B0503020000020004" pitchFamily="50" charset="-127"/>
-            </a:endParaRPr>
+            <a:endParaRPr lang="ko-KR" altLang="en-US"/>
           </a:p>
         </p:txBody>
       </p:sp>

</xml_diff>